<commit_message>
Apply cream theme, MCA department, and updated student profiles
</commit_message>
<xml_diff>
--- a/presentation/personalized_report_presentation.pptx
+++ b/presentation/personalized_report_presentation.pptx
@@ -3093,7 +3093,7 @@
     <p:bg>
       <p:bgPr>
         <a:solidFill>
-          <a:srgbClr val="FFFFFF"/>
+          <a:srgbClr val="FDFBFF"/>
         </a:solidFill>
         <a:effectLst/>
       </p:bgPr>
@@ -3107,24 +3107,76 @@
       <p:grpSpPr/>
       <p:sp>
         <p:nvSpPr>
-          <p:cNvPr id="2" name="Rectangle 1"/>
+          <p:cNvPr id="2" name="TextBox 1"/>
+          <p:cNvSpPr txBox="1"/>
+          <p:nvPr/>
+        </p:nvSpPr>
+        <p:spPr>
+          <a:xfrm>
+            <a:off x="731520" y="320040"/>
+            <a:ext cx="10728655" cy="1051560"/>
+          </a:xfrm>
+          <a:prstGeom prst="rect">
+            <a:avLst/>
+          </a:prstGeom>
+          <a:noFill/>
+        </p:spPr>
+        <p:txBody>
+          <a:bodyPr wrap="square" lIns="0" tIns="0" rIns="0" bIns="0">
+            <a:spAutoFit/>
+          </a:bodyPr>
+          <a:lstStyle/>
+          <a:p>
+            <a:pPr>
+              <a:defRPr sz="3400" b="1">
+                <a:solidFill>
+                  <a:srgbClr val="3B0764"/>
+                </a:solidFill>
+                <a:latin typeface="Calibri"/>
+              </a:defRPr>
+            </a:pPr>
+            <a:r>
+              <a:t>Personalized Report Generation using Templates and Python</a:t>
+            </a:r>
+          </a:p>
+          <a:p>
+            <a:pPr>
+              <a:spcBef>
+                <a:spcPts val="400"/>
+              </a:spcBef>
+              <a:defRPr sz="2200" b="1">
+                <a:solidFill>
+                  <a:srgbClr val="581C87"/>
+                </a:solidFill>
+                <a:latin typeface="Calibri"/>
+              </a:defRPr>
+            </a:pPr>
+            <a:r>
+              <a:t>Automated Academic Performance Appraisal &amp; PDF Compilation System</a:t>
+            </a:r>
+          </a:p>
+        </p:txBody>
+      </p:sp>
+      <p:sp>
+        <p:nvSpPr>
+          <p:cNvPr id="3" name="Rectangle 2"/>
           <p:cNvSpPr/>
           <p:nvPr/>
         </p:nvSpPr>
         <p:spPr>
           <a:xfrm>
-            <a:off x="731520" y="731520"/>
-            <a:ext cx="10698480" cy="91440"/>
+            <a:off x="731520" y="1417320"/>
+            <a:ext cx="10728655" cy="36576"/>
           </a:xfrm>
           <a:prstGeom prst="rect">
             <a:avLst/>
           </a:prstGeom>
           <a:solidFill>
-            <a:srgbClr val="3B0764"/>
+            <a:srgbClr val="581C87"/>
           </a:solidFill>
           <a:ln>
             <a:solidFill>
-              <a:srgbClr val="3B0764"/>
+              <a:srgbClr val="581C87"/>
             </a:solidFill>
           </a:ln>
         </p:spPr>
@@ -3152,72 +3204,20 @@
       </p:sp>
       <p:sp>
         <p:nvSpPr>
-          <p:cNvPr id="3" name="TextBox 2"/>
-          <p:cNvSpPr txBox="1"/>
-          <p:nvPr/>
-        </p:nvSpPr>
-        <p:spPr>
-          <a:xfrm>
-            <a:off x="731520" y="1188720"/>
-            <a:ext cx="10698480" cy="1280160"/>
-          </a:xfrm>
-          <a:prstGeom prst="rect">
-            <a:avLst/>
-          </a:prstGeom>
-          <a:noFill/>
-        </p:spPr>
-        <p:txBody>
-          <a:bodyPr wrap="square">
-            <a:spAutoFit/>
-          </a:bodyPr>
-          <a:lstStyle/>
-          <a:p>
-            <a:pPr>
-              <a:defRPr sz="3500" b="1">
-                <a:solidFill>
-                  <a:srgbClr val="3B0764"/>
-                </a:solidFill>
-                <a:latin typeface="Calibri"/>
-              </a:defRPr>
-            </a:pPr>
-            <a:r>
-              <a:t>Personalized Report Generation using Templates and Python</a:t>
-            </a:r>
-          </a:p>
-          <a:p>
-            <a:pPr>
-              <a:spcBef>
-                <a:spcPts val="800"/>
-              </a:spcBef>
-              <a:defRPr sz="2500" b="1">
-                <a:solidFill>
-                  <a:srgbClr val="581C87"/>
-                </a:solidFill>
-                <a:latin typeface="Calibri"/>
-              </a:defRPr>
-            </a:pPr>
-            <a:r>
-              <a:t>Automated Academic Performance Appraisal &amp; PDF Compilation System</a:t>
-            </a:r>
-          </a:p>
-        </p:txBody>
-      </p:sp>
-      <p:sp>
-        <p:nvSpPr>
           <p:cNvPr id="4" name="Rounded Rectangle 3"/>
           <p:cNvSpPr/>
           <p:nvPr/>
         </p:nvSpPr>
         <p:spPr>
           <a:xfrm>
-            <a:off x="731520" y="2926080"/>
-            <a:ext cx="10698480" cy="3017520"/>
+            <a:off x="731520" y="1600200"/>
+            <a:ext cx="5212080" cy="4480560"/>
           </a:xfrm>
           <a:prstGeom prst="roundRect">
             <a:avLst/>
           </a:prstGeom>
           <a:solidFill>
-            <a:srgbClr val="F3E8FF"/>
+            <a:srgbClr val="F5F0FF"/>
           </a:solidFill>
           <a:ln w="19050">
             <a:solidFill>
@@ -3255,8 +3255,8 @@
         </p:nvSpPr>
         <p:spPr>
           <a:xfrm>
-            <a:off x="1097280" y="3108960"/>
-            <a:ext cx="9966960" cy="2651760"/>
+            <a:off x="960120" y="1783080"/>
+            <a:ext cx="4754880" cy="4114800"/>
           </a:xfrm>
           <a:prstGeom prst="rect">
             <a:avLst/>
@@ -3274,11 +3274,11 @@
                 <a:spcPts val="400"/>
               </a:spcBef>
               <a:spcAft>
-                <a:spcPts val="1200"/>
+                <a:spcPts val="1400"/>
               </a:spcAft>
             </a:pPr>
             <a:r>
-              <a:rPr sz="2000" b="1">
+              <a:rPr sz="1900" b="1">
                 <a:solidFill>
                   <a:srgbClr val="3B0764"/>
                 </a:solidFill>
@@ -3287,13 +3287,13 @@
               <a:t>• Academic Context: </a:t>
             </a:r>
             <a:r>
-              <a:rPr sz="2000" b="0">
+              <a:rPr sz="1700" b="0">
                 <a:solidFill>
                   <a:srgbClr val="1E1B4B"/>
                 </a:solidFill>
                 <a:latin typeface="Calibri"/>
               </a:rPr>
-              <a:t>Postgraduate Seminar Coursework in Advanced Python Programming.</a:t>
+              <a:t>Postgraduate Coursework in Advanced Python Programming.</a:t>
             </a:r>
           </a:p>
           <a:p>
@@ -3302,26 +3302,26 @@
                 <a:spcPts val="400"/>
               </a:spcBef>
               <a:spcAft>
-                <a:spcPts val="1200"/>
+                <a:spcPts val="1400"/>
               </a:spcAft>
             </a:pPr>
             <a:r>
-              <a:rPr sz="2000" b="1">
+              <a:rPr sz="1900" b="1">
                 <a:solidFill>
                   <a:srgbClr val="3B0764"/>
                 </a:solidFill>
                 <a:latin typeface="Calibri"/>
               </a:rPr>
-              <a:t>• Core Technology: </a:t>
-            </a:r>
-            <a:r>
-              <a:rPr sz="2000" b="0">
+              <a:t>• Core Stack: </a:t>
+            </a:r>
+            <a:r>
+              <a:rPr sz="1700" b="0">
                 <a:solidFill>
                   <a:srgbClr val="1E1B4B"/>
                 </a:solidFill>
                 <a:latin typeface="Calibri"/>
               </a:rPr>
-              <a:t>Python 3, Streamlit (Web UI), Pandas (Data), Matplotlib (Charts), ReportLab (PDFs).</a:t>
+              <a:t>Python 3, Streamlit (UI), Pandas, Matplotlib, ReportLab.</a:t>
             </a:r>
           </a:p>
           <a:p>
@@ -3330,26 +3330,26 @@
                 <a:spcPts val="400"/>
               </a:spcBef>
               <a:spcAft>
-                <a:spcPts val="1200"/>
+                <a:spcPts val="1400"/>
               </a:spcAft>
             </a:pPr>
             <a:r>
-              <a:rPr sz="2000" b="1">
+              <a:rPr sz="1900" b="1">
                 <a:solidFill>
                   <a:srgbClr val="3B0764"/>
                 </a:solidFill>
                 <a:latin typeface="Calibri"/>
               </a:rPr>
-              <a:t>• Key Philosophy: </a:t>
-            </a:r>
-            <a:r>
-              <a:rPr sz="2000" b="0">
+              <a:t>• Architecture: </a:t>
+            </a:r>
+            <a:r>
+              <a:rPr sz="1700" b="0">
                 <a:solidFill>
                   <a:srgbClr val="1E1B4B"/>
                 </a:solidFill>
                 <a:latin typeface="Calibri"/>
               </a:rPr>
-              <a:t>100% Free &amp; Open-Source Stack — Zero external APIs, databases, or cloud costs.</a:t>
+              <a:t>Decoupled Template Design with In-Memory Byte Streaming.</a:t>
             </a:r>
           </a:p>
           <a:p>
@@ -3358,40 +3358,109 @@
                 <a:spcPts val="400"/>
               </a:spcBef>
               <a:spcAft>
-                <a:spcPts val="1200"/>
+                <a:spcPts val="1400"/>
               </a:spcAft>
             </a:pPr>
             <a:r>
-              <a:rPr sz="2000" b="1">
+              <a:rPr sz="1900" b="1">
                 <a:solidFill>
                   <a:srgbClr val="3B0764"/>
                 </a:solidFill>
                 <a:latin typeface="Calibri"/>
               </a:rPr>
-              <a:t>• Architecture: </a:t>
-            </a:r>
-            <a:r>
-              <a:rPr sz="2000" b="0">
+              <a:t>• Zero Cost: </a:t>
+            </a:r>
+            <a:r>
+              <a:rPr sz="1700" b="0">
                 <a:solidFill>
                   <a:srgbClr val="1E1B4B"/>
                 </a:solidFill>
                 <a:latin typeface="Calibri"/>
               </a:rPr>
-              <a:t>Template Decoupled Design with In-Memory Byte Buffer Streaming (io.BytesIO).</a:t>
-            </a:r>
-          </a:p>
-        </p:txBody>
-      </p:sp>
-      <p:sp>
-        <p:nvSpPr>
-          <p:cNvPr id="6" name="TextBox 5"/>
+              <a:t>100% Free &amp; Open-Source — No cloud fees or paid APIs.</a:t>
+            </a:r>
+          </a:p>
+        </p:txBody>
+      </p:sp>
+      <p:pic>
+        <p:nvPicPr>
+          <p:cNvPr id="6" name="Picture 5" descr="slide1_hero.png"/>
+          <p:cNvPicPr>
+            <a:picLocks noChangeAspect="1"/>
+          </p:cNvPicPr>
+          <p:nvPr/>
+        </p:nvPicPr>
+        <p:blipFill>
+          <a:blip r:embed="rId2"/>
+          <a:stretch>
+            <a:fillRect/>
+          </a:stretch>
+        </p:blipFill>
+        <p:spPr>
+          <a:xfrm>
+            <a:off x="6217920" y="1600200"/>
+            <a:ext cx="5212080" cy="3451242"/>
+          </a:xfrm>
+          <a:prstGeom prst="rect">
+            <a:avLst/>
+          </a:prstGeom>
+        </p:spPr>
+      </p:pic>
+      <p:sp>
+        <p:nvSpPr>
+          <p:cNvPr id="7" name="Rectangle 6"/>
+          <p:cNvSpPr/>
+          <p:nvPr/>
+        </p:nvSpPr>
+        <p:spPr>
+          <a:xfrm>
+            <a:off x="731520" y="6263640"/>
+            <a:ext cx="10728655" cy="18288"/>
+          </a:xfrm>
+          <a:prstGeom prst="rect">
+            <a:avLst/>
+          </a:prstGeom>
+          <a:solidFill>
+            <a:srgbClr val="D8B4FE"/>
+          </a:solidFill>
+          <a:ln>
+            <a:solidFill>
+              <a:srgbClr val="D8B4FE"/>
+            </a:solidFill>
+          </a:ln>
+        </p:spPr>
+        <p:style>
+          <a:lnRef idx="1">
+            <a:schemeClr val="accent1"/>
+          </a:lnRef>
+          <a:fillRef idx="3">
+            <a:schemeClr val="accent1"/>
+          </a:fillRef>
+          <a:effectRef idx="2">
+            <a:schemeClr val="accent1"/>
+          </a:effectRef>
+          <a:fontRef idx="minor">
+            <a:schemeClr val="lt1"/>
+          </a:fontRef>
+        </p:style>
+        <p:txBody>
+          <a:bodyPr rtlCol="0" anchor="ctr"/>
+          <a:lstStyle/>
+          <a:p>
+            <a:pPr algn="ctr"/>
+          </a:p>
+        </p:txBody>
+      </p:sp>
+      <p:sp>
+        <p:nvSpPr>
+          <p:cNvPr id="8" name="TextBox 7"/>
           <p:cNvSpPr txBox="1"/>
           <p:nvPr/>
         </p:nvSpPr>
         <p:spPr>
           <a:xfrm>
-            <a:off x="731520" y="6446520"/>
-            <a:ext cx="10698480" cy="320040"/>
+            <a:off x="731520" y="6327648"/>
+            <a:ext cx="10728655" cy="365760"/>
           </a:xfrm>
           <a:prstGeom prst="rect">
             <a:avLst/>
@@ -3405,9 +3474,9 @@
           <a:lstStyle/>
           <a:p>
             <a:pPr>
-              <a:defRPr sz="1100">
-                <a:solidFill>
-                  <a:srgbClr val="6B7280"/>
+              <a:defRPr sz="1600" b="1">
+                <a:solidFill>
+                  <a:srgbClr val="6B468C"/>
                 </a:solidFill>
                 <a:latin typeface="Calibri"/>
               </a:defRPr>
@@ -3432,7 +3501,7 @@
     <p:bg>
       <p:bgPr>
         <a:solidFill>
-          <a:srgbClr val="FFFFFF"/>
+          <a:srgbClr val="FDFBFF"/>
         </a:solidFill>
         <a:effectLst/>
       </p:bgPr>
@@ -3452,8 +3521,8 @@
         </p:nvSpPr>
         <p:spPr>
           <a:xfrm>
-            <a:off x="731520" y="365760"/>
-            <a:ext cx="10698480" cy="1005840"/>
+            <a:off x="731520" y="320040"/>
+            <a:ext cx="10728655" cy="1051560"/>
           </a:xfrm>
           <a:prstGeom prst="rect">
             <a:avLst/>
@@ -3467,7 +3536,7 @@
           <a:lstStyle/>
           <a:p>
             <a:pPr>
-              <a:defRPr sz="3500" b="1">
+              <a:defRPr sz="3400" b="1">
                 <a:solidFill>
                   <a:srgbClr val="3B0764"/>
                 </a:solidFill>
@@ -3480,7 +3549,10 @@
           </a:p>
           <a:p>
             <a:pPr>
-              <a:defRPr sz="2500" b="1">
+              <a:spcBef>
+                <a:spcPts val="400"/>
+              </a:spcBef>
+              <a:defRPr sz="2200" b="1">
                 <a:solidFill>
                   <a:srgbClr val="581C87"/>
                 </a:solidFill>
@@ -3488,7 +3560,7 @@
               </a:defRPr>
             </a:pPr>
             <a:r>
-              <a:t>Project Summary &amp; Advanced Scalability Roadmap</a:t>
+              <a:t>Project Accomplishments &amp; Enterprise Scalability Roadmap</a:t>
             </a:r>
           </a:p>
         </p:txBody>
@@ -3501,8 +3573,8 @@
         </p:nvSpPr>
         <p:spPr>
           <a:xfrm>
-            <a:off x="731520" y="1371600"/>
-            <a:ext cx="10698480" cy="36576"/>
+            <a:off x="731520" y="1417320"/>
+            <a:ext cx="10728655" cy="36576"/>
           </a:xfrm>
           <a:prstGeom prst="rect">
             <a:avLst/>
@@ -3540,14 +3612,218 @@
       </p:sp>
       <p:sp>
         <p:nvSpPr>
-          <p:cNvPr id="4" name="Rectangle 3"/>
+          <p:cNvPr id="4" name="Rounded Rectangle 3"/>
           <p:cNvSpPr/>
           <p:nvPr/>
         </p:nvSpPr>
         <p:spPr>
           <a:xfrm>
-            <a:off x="731520" y="6400800"/>
-            <a:ext cx="10698480" cy="18288"/>
+            <a:off x="731520" y="1600200"/>
+            <a:ext cx="5212080" cy="4480560"/>
+          </a:xfrm>
+          <a:prstGeom prst="roundRect">
+            <a:avLst/>
+          </a:prstGeom>
+          <a:solidFill>
+            <a:srgbClr val="F5F0FF"/>
+          </a:solidFill>
+          <a:ln w="19050">
+            <a:solidFill>
+              <a:srgbClr val="D8B4FE"/>
+            </a:solidFill>
+          </a:ln>
+        </p:spPr>
+        <p:style>
+          <a:lnRef idx="1">
+            <a:schemeClr val="accent1"/>
+          </a:lnRef>
+          <a:fillRef idx="3">
+            <a:schemeClr val="accent1"/>
+          </a:fillRef>
+          <a:effectRef idx="2">
+            <a:schemeClr val="accent1"/>
+          </a:effectRef>
+          <a:fontRef idx="minor">
+            <a:schemeClr val="lt1"/>
+          </a:fontRef>
+        </p:style>
+        <p:txBody>
+          <a:bodyPr rtlCol="0" anchor="ctr"/>
+          <a:lstStyle/>
+          <a:p>
+            <a:pPr algn="ctr"/>
+          </a:p>
+        </p:txBody>
+      </p:sp>
+      <p:sp>
+        <p:nvSpPr>
+          <p:cNvPr id="5" name="TextBox 4"/>
+          <p:cNvSpPr txBox="1"/>
+          <p:nvPr/>
+        </p:nvSpPr>
+        <p:spPr>
+          <a:xfrm>
+            <a:off x="960120" y="1783080"/>
+            <a:ext cx="4754880" cy="4114800"/>
+          </a:xfrm>
+          <a:prstGeom prst="rect">
+            <a:avLst/>
+          </a:prstGeom>
+          <a:noFill/>
+        </p:spPr>
+        <p:txBody>
+          <a:bodyPr wrap="square" lIns="0" tIns="0" rIns="0" bIns="0">
+            <a:spAutoFit/>
+          </a:bodyPr>
+          <a:lstStyle/>
+          <a:p>
+            <a:pPr>
+              <a:spcBef>
+                <a:spcPts val="400"/>
+              </a:spcBef>
+              <a:spcAft>
+                <a:spcPts val="1400"/>
+              </a:spcAft>
+            </a:pPr>
+            <a:r>
+              <a:rPr sz="1900" b="1">
+                <a:solidFill>
+                  <a:srgbClr val="3B0764"/>
+                </a:solidFill>
+                <a:latin typeface="Calibri"/>
+              </a:rPr>
+              <a:t>• 100% Automated: </a:t>
+            </a:r>
+            <a:r>
+              <a:rPr sz="1700" b="0">
+                <a:solidFill>
+                  <a:srgbClr val="1E1B4B"/>
+                </a:solidFill>
+                <a:latin typeface="Calibri"/>
+              </a:rPr>
+              <a:t>Eliminates administrative overhead and arithmetic errors.</a:t>
+            </a:r>
+          </a:p>
+          <a:p>
+            <a:pPr>
+              <a:spcBef>
+                <a:spcPts val="400"/>
+              </a:spcBef>
+              <a:spcAft>
+                <a:spcPts val="1400"/>
+              </a:spcAft>
+            </a:pPr>
+            <a:r>
+              <a:rPr sz="1900" b="1">
+                <a:solidFill>
+                  <a:srgbClr val="3B0764"/>
+                </a:solidFill>
+                <a:latin typeface="Calibri"/>
+              </a:rPr>
+              <a:t>• High Performance: </a:t>
+            </a:r>
+            <a:r>
+              <a:rPr sz="1700" b="0">
+                <a:solidFill>
+                  <a:srgbClr val="1E1B4B"/>
+                </a:solidFill>
+                <a:latin typeface="Calibri"/>
+              </a:rPr>
+              <a:t>Under 0.8s execution time via in-memory streaming.</a:t>
+            </a:r>
+          </a:p>
+          <a:p>
+            <a:pPr>
+              <a:spcBef>
+                <a:spcPts val="400"/>
+              </a:spcBef>
+              <a:spcAft>
+                <a:spcPts val="1400"/>
+              </a:spcAft>
+            </a:pPr>
+            <a:r>
+              <a:rPr sz="1900" b="1">
+                <a:solidFill>
+                  <a:srgbClr val="3B0764"/>
+                </a:solidFill>
+                <a:latin typeface="Calibri"/>
+              </a:rPr>
+              <a:t>• Scalability Roadmap: </a:t>
+            </a:r>
+            <a:r>
+              <a:rPr sz="1700" b="0">
+                <a:solidFill>
+                  <a:srgbClr val="1E1B4B"/>
+                </a:solidFill>
+                <a:latin typeface="Calibri"/>
+              </a:rPr>
+              <a:t>Batch CSV ingestion for 500+ students &amp; email dispatch.</a:t>
+            </a:r>
+          </a:p>
+          <a:p>
+            <a:pPr>
+              <a:spcBef>
+                <a:spcPts val="400"/>
+              </a:spcBef>
+              <a:spcAft>
+                <a:spcPts val="1400"/>
+              </a:spcAft>
+            </a:pPr>
+            <a:r>
+              <a:rPr sz="1900" b="1">
+                <a:solidFill>
+                  <a:srgbClr val="3B0764"/>
+                </a:solidFill>
+                <a:latin typeface="Calibri"/>
+              </a:rPr>
+              <a:t>• Viva Evaluation: </a:t>
+            </a:r>
+            <a:r>
+              <a:rPr sz="1700" b="0">
+                <a:solidFill>
+                  <a:srgbClr val="1E1B4B"/>
+                </a:solidFill>
+                <a:latin typeface="Calibri"/>
+              </a:rPr>
+              <a:t>Floor is open for Questions, Code Walkthrough &amp; Demo.</a:t>
+            </a:r>
+          </a:p>
+        </p:txBody>
+      </p:sp>
+      <p:pic>
+        <p:nvPicPr>
+          <p:cNvPr id="6" name="Picture 5" descr="slide10_roadmap.png"/>
+          <p:cNvPicPr>
+            <a:picLocks noChangeAspect="1"/>
+          </p:cNvPicPr>
+          <p:nvPr/>
+        </p:nvPicPr>
+        <p:blipFill>
+          <a:blip r:embed="rId2"/>
+          <a:stretch>
+            <a:fillRect/>
+          </a:stretch>
+        </p:blipFill>
+        <p:spPr>
+          <a:xfrm>
+            <a:off x="6217920" y="1600200"/>
+            <a:ext cx="5212080" cy="3451242"/>
+          </a:xfrm>
+          <a:prstGeom prst="rect">
+            <a:avLst/>
+          </a:prstGeom>
+        </p:spPr>
+      </p:pic>
+      <p:sp>
+        <p:nvSpPr>
+          <p:cNvPr id="7" name="Rectangle 6"/>
+          <p:cNvSpPr/>
+          <p:nvPr/>
+        </p:nvSpPr>
+        <p:spPr>
+          <a:xfrm>
+            <a:off x="731520" y="6263640"/>
+            <a:ext cx="10728655" cy="18288"/>
           </a:xfrm>
           <a:prstGeom prst="rect">
             <a:avLst/>
@@ -3585,14 +3861,14 @@
       </p:sp>
       <p:sp>
         <p:nvSpPr>
-          <p:cNvPr id="5" name="TextBox 4"/>
+          <p:cNvPr id="8" name="TextBox 7"/>
           <p:cNvSpPr txBox="1"/>
           <p:nvPr/>
         </p:nvSpPr>
         <p:spPr>
           <a:xfrm>
-            <a:off x="731520" y="1645920"/>
-            <a:ext cx="10698480" cy="4572000"/>
+            <a:off x="731520" y="6327648"/>
+            <a:ext cx="10728655" cy="365760"/>
           </a:xfrm>
           <a:prstGeom prst="rect">
             <a:avLst/>
@@ -3600,178 +3876,15 @@
           <a:noFill/>
         </p:spPr>
         <p:txBody>
-          <a:bodyPr wrap="square" lIns="0" tIns="0" rIns="0" bIns="0">
-            <a:spAutoFit/>
-          </a:bodyPr>
-          <a:lstStyle/>
-          <a:p>
-            <a:pPr>
-              <a:spcBef>
-                <a:spcPts val="400"/>
-              </a:spcBef>
-              <a:spcAft>
-                <a:spcPts val="1200"/>
-              </a:spcAft>
-            </a:pPr>
-            <a:r>
-              <a:rPr sz="2000" b="1">
-                <a:solidFill>
-                  <a:srgbClr val="3B0764"/>
-                </a:solidFill>
-                <a:latin typeface="Calibri"/>
-              </a:rPr>
-              <a:t>• Key Accomplishments: </a:t>
-            </a:r>
-            <a:r>
-              <a:rPr sz="2000" b="0">
-                <a:solidFill>
-                  <a:srgbClr val="1E1B4B"/>
-                </a:solidFill>
-                <a:latin typeface="Calibri"/>
-              </a:rPr>
-              <a:t>Delivered an automated, zero-cost, template-driven report generator.</a:t>
-            </a:r>
-          </a:p>
-          <a:p>
-            <a:pPr>
-              <a:spcBef>
-                <a:spcPts val="400"/>
-              </a:spcBef>
-              <a:spcAft>
-                <a:spcPts val="1200"/>
-              </a:spcAft>
-            </a:pPr>
-            <a:r>
-              <a:rPr sz="2000" b="1">
-                <a:solidFill>
-                  <a:srgbClr val="3B0764"/>
-                </a:solidFill>
-                <a:latin typeface="Calibri"/>
-              </a:rPr>
-              <a:t>• High Memory Efficiency: </a:t>
-            </a:r>
-            <a:r>
-              <a:rPr sz="2000" b="0">
-                <a:solidFill>
-                  <a:srgbClr val="1E1B4B"/>
-                </a:solidFill>
-                <a:latin typeface="Calibri"/>
-              </a:rPr>
-              <a:t>In-memory streaming (io.BytesIO) prevents disk clutter and file locking.</a:t>
-            </a:r>
-          </a:p>
-          <a:p>
-            <a:pPr>
-              <a:spcBef>
-                <a:spcPts val="400"/>
-              </a:spcBef>
-              <a:spcAft>
-                <a:spcPts val="1200"/>
-              </a:spcAft>
-            </a:pPr>
-            <a:r>
-              <a:rPr sz="2000" b="1">
-                <a:solidFill>
-                  <a:srgbClr val="3B0764"/>
-                </a:solidFill>
-                <a:latin typeface="Calibri"/>
-              </a:rPr>
-              <a:t>• Scalability Roadmap: </a:t>
-            </a:r>
-            <a:r>
-              <a:rPr sz="2000" b="0">
-                <a:solidFill>
-                  <a:srgbClr val="1E1B4B"/>
-                </a:solidFill>
-                <a:latin typeface="Calibri"/>
-              </a:rPr>
-              <a:t>Can easily extend to batch CSV processing for 500+ students and email dispatch.</a:t>
-            </a:r>
-          </a:p>
-          <a:p>
-            <a:pPr>
-              <a:spcBef>
-                <a:spcPts val="400"/>
-              </a:spcBef>
-              <a:spcAft>
-                <a:spcPts val="1200"/>
-              </a:spcAft>
-            </a:pPr>
-            <a:r>
-              <a:rPr sz="2000" b="1">
-                <a:solidFill>
-                  <a:srgbClr val="3B0764"/>
-                </a:solidFill>
-                <a:latin typeface="Calibri"/>
-              </a:rPr>
-              <a:t>• Advanced Extensions: </a:t>
-            </a:r>
-            <a:r>
-              <a:rPr sz="2000" b="0">
-                <a:solidFill>
-                  <a:srgbClr val="1E1B4B"/>
-                </a:solidFill>
-                <a:latin typeface="Calibri"/>
-              </a:rPr>
-              <a:t>Longitudinal trend tracking across semesters &amp; institutional LMS integration.</a:t>
-            </a:r>
-          </a:p>
-          <a:p>
-            <a:pPr>
-              <a:spcBef>
-                <a:spcPts val="400"/>
-              </a:spcBef>
-              <a:spcAft>
-                <a:spcPts val="1200"/>
-              </a:spcAft>
-            </a:pPr>
-            <a:r>
-              <a:rPr sz="2000" b="1">
-                <a:solidFill>
-                  <a:srgbClr val="3B0764"/>
-                </a:solidFill>
-                <a:latin typeface="Calibri"/>
-              </a:rPr>
-              <a:t>• Thank You: </a:t>
-            </a:r>
-            <a:r>
-              <a:rPr sz="2000" b="0">
-                <a:solidFill>
-                  <a:srgbClr val="1E1B4B"/>
-                </a:solidFill>
-                <a:latin typeface="Calibri"/>
-              </a:rPr>
-              <a:t>Floor is open for Questions, Code Walkthrough, and Viva Evaluation.</a:t>
-            </a:r>
-          </a:p>
-        </p:txBody>
-      </p:sp>
-      <p:sp>
-        <p:nvSpPr>
-          <p:cNvPr id="6" name="TextBox 5"/>
-          <p:cNvSpPr txBox="1"/>
-          <p:nvPr/>
-        </p:nvSpPr>
-        <p:spPr>
-          <a:xfrm>
-            <a:off x="731520" y="6446520"/>
-            <a:ext cx="10698480" cy="320040"/>
-          </a:xfrm>
-          <a:prstGeom prst="rect">
-            <a:avLst/>
-          </a:prstGeom>
-          <a:noFill/>
-        </p:spPr>
-        <p:txBody>
           <a:bodyPr wrap="none">
             <a:spAutoFit/>
           </a:bodyPr>
           <a:lstStyle/>
           <a:p>
             <a:pPr>
-              <a:defRPr sz="1100">
-                <a:solidFill>
-                  <a:srgbClr val="6B7280"/>
+              <a:defRPr sz="1600" b="1">
+                <a:solidFill>
+                  <a:srgbClr val="6B468C"/>
                 </a:solidFill>
                 <a:latin typeface="Calibri"/>
               </a:defRPr>
@@ -3796,7 +3909,7 @@
     <p:bg>
       <p:bgPr>
         <a:solidFill>
-          <a:srgbClr val="FFFFFF"/>
+          <a:srgbClr val="FDFBFF"/>
         </a:solidFill>
         <a:effectLst/>
       </p:bgPr>
@@ -3816,8 +3929,8 @@
         </p:nvSpPr>
         <p:spPr>
           <a:xfrm>
-            <a:off x="731520" y="365760"/>
-            <a:ext cx="10698480" cy="1005840"/>
+            <a:off x="731520" y="320040"/>
+            <a:ext cx="10728655" cy="1051560"/>
           </a:xfrm>
           <a:prstGeom prst="rect">
             <a:avLst/>
@@ -3831,7 +3944,7 @@
           <a:lstStyle/>
           <a:p>
             <a:pPr>
-              <a:defRPr sz="3500" b="1">
+              <a:defRPr sz="3400" b="1">
                 <a:solidFill>
                   <a:srgbClr val="3B0764"/>
                 </a:solidFill>
@@ -3844,7 +3957,10 @@
           </a:p>
           <a:p>
             <a:pPr>
-              <a:defRPr sz="2500" b="1">
+              <a:spcBef>
+                <a:spcPts val="400"/>
+              </a:spcBef>
+              <a:defRPr sz="2200" b="1">
                 <a:solidFill>
                   <a:srgbClr val="581C87"/>
                 </a:solidFill>
@@ -3852,7 +3968,7 @@
               </a:defRPr>
             </a:pPr>
             <a:r>
-              <a:t>Challenges in Traditional Student Progress Reporting</a:t>
+              <a:t>Challenges in Traditional Student Progress Appraisal</a:t>
             </a:r>
           </a:p>
         </p:txBody>
@@ -3865,8 +3981,8 @@
         </p:nvSpPr>
         <p:spPr>
           <a:xfrm>
-            <a:off x="731520" y="1371600"/>
-            <a:ext cx="10698480" cy="36576"/>
+            <a:off x="731520" y="1417320"/>
+            <a:ext cx="10728655" cy="36576"/>
           </a:xfrm>
           <a:prstGeom prst="rect">
             <a:avLst/>
@@ -3904,14 +4020,218 @@
       </p:sp>
       <p:sp>
         <p:nvSpPr>
-          <p:cNvPr id="4" name="Rectangle 3"/>
+          <p:cNvPr id="4" name="Rounded Rectangle 3"/>
           <p:cNvSpPr/>
           <p:nvPr/>
         </p:nvSpPr>
         <p:spPr>
           <a:xfrm>
-            <a:off x="731520" y="6400800"/>
-            <a:ext cx="10698480" cy="18288"/>
+            <a:off x="731520" y="1600200"/>
+            <a:ext cx="5212080" cy="4480560"/>
+          </a:xfrm>
+          <a:prstGeom prst="roundRect">
+            <a:avLst/>
+          </a:prstGeom>
+          <a:solidFill>
+            <a:srgbClr val="F5F0FF"/>
+          </a:solidFill>
+          <a:ln w="19050">
+            <a:solidFill>
+              <a:srgbClr val="D8B4FE"/>
+            </a:solidFill>
+          </a:ln>
+        </p:spPr>
+        <p:style>
+          <a:lnRef idx="1">
+            <a:schemeClr val="accent1"/>
+          </a:lnRef>
+          <a:fillRef idx="3">
+            <a:schemeClr val="accent1"/>
+          </a:fillRef>
+          <a:effectRef idx="2">
+            <a:schemeClr val="accent1"/>
+          </a:effectRef>
+          <a:fontRef idx="minor">
+            <a:schemeClr val="lt1"/>
+          </a:fontRef>
+        </p:style>
+        <p:txBody>
+          <a:bodyPr rtlCol="0" anchor="ctr"/>
+          <a:lstStyle/>
+          <a:p>
+            <a:pPr algn="ctr"/>
+          </a:p>
+        </p:txBody>
+      </p:sp>
+      <p:sp>
+        <p:nvSpPr>
+          <p:cNvPr id="5" name="TextBox 4"/>
+          <p:cNvSpPr txBox="1"/>
+          <p:nvPr/>
+        </p:nvSpPr>
+        <p:spPr>
+          <a:xfrm>
+            <a:off x="960120" y="1783080"/>
+            <a:ext cx="4754880" cy="4114800"/>
+          </a:xfrm>
+          <a:prstGeom prst="rect">
+            <a:avLst/>
+          </a:prstGeom>
+          <a:noFill/>
+        </p:spPr>
+        <p:txBody>
+          <a:bodyPr wrap="square" lIns="0" tIns="0" rIns="0" bIns="0">
+            <a:spAutoFit/>
+          </a:bodyPr>
+          <a:lstStyle/>
+          <a:p>
+            <a:pPr>
+              <a:spcBef>
+                <a:spcPts val="400"/>
+              </a:spcBef>
+              <a:spcAft>
+                <a:spcPts val="1400"/>
+              </a:spcAft>
+            </a:pPr>
+            <a:r>
+              <a:rPr sz="1900" b="1">
+                <a:solidFill>
+                  <a:srgbClr val="3B0764"/>
+                </a:solidFill>
+                <a:latin typeface="Calibri"/>
+              </a:rPr>
+              <a:t>• Administrative Burden: </a:t>
+            </a:r>
+            <a:r>
+              <a:rPr sz="1700" b="0">
+                <a:solidFill>
+                  <a:srgbClr val="1E1B4B"/>
+                </a:solidFill>
+                <a:latin typeface="Calibri"/>
+              </a:rPr>
+              <a:t>Manual spreadsheet reporting takes hours per batch.</a:t>
+            </a:r>
+          </a:p>
+          <a:p>
+            <a:pPr>
+              <a:spcBef>
+                <a:spcPts val="400"/>
+              </a:spcBef>
+              <a:spcAft>
+                <a:spcPts val="1400"/>
+              </a:spcAft>
+            </a:pPr>
+            <a:r>
+              <a:rPr sz="1900" b="1">
+                <a:solidFill>
+                  <a:srgbClr val="3B0764"/>
+                </a:solidFill>
+                <a:latin typeface="Calibri"/>
+              </a:rPr>
+              <a:t>• Calculation Errors: </a:t>
+            </a:r>
+            <a:r>
+              <a:rPr sz="1700" b="0">
+                <a:solidFill>
+                  <a:srgbClr val="1E1B4B"/>
+                </a:solidFill>
+                <a:latin typeface="Calibri"/>
+              </a:rPr>
+              <a:t>Averaging and grading manual mistakes harm accuracy.</a:t>
+            </a:r>
+          </a:p>
+          <a:p>
+            <a:pPr>
+              <a:spcBef>
+                <a:spcPts val="400"/>
+              </a:spcBef>
+              <a:spcAft>
+                <a:spcPts val="1400"/>
+              </a:spcAft>
+            </a:pPr>
+            <a:r>
+              <a:rPr sz="1900" b="1">
+                <a:solidFill>
+                  <a:srgbClr val="3B0764"/>
+                </a:solidFill>
+                <a:latin typeface="Calibri"/>
+              </a:rPr>
+              <a:t>• Lack of Guidance: </a:t>
+            </a:r>
+            <a:r>
+              <a:rPr sz="1700" b="0">
+                <a:solidFill>
+                  <a:srgbClr val="1E1B4B"/>
+                </a:solidFill>
+                <a:latin typeface="Calibri"/>
+              </a:rPr>
+              <a:t>Standard report cards omit personalized remedial advice.</a:t>
+            </a:r>
+          </a:p>
+          <a:p>
+            <a:pPr>
+              <a:spcBef>
+                <a:spcPts val="400"/>
+              </a:spcBef>
+              <a:spcAft>
+                <a:spcPts val="1400"/>
+              </a:spcAft>
+            </a:pPr>
+            <a:r>
+              <a:rPr sz="1900" b="1">
+                <a:solidFill>
+                  <a:srgbClr val="3B0764"/>
+                </a:solidFill>
+                <a:latin typeface="Calibri"/>
+              </a:rPr>
+              <a:t>• Absent Visual Analytics: </a:t>
+            </a:r>
+            <a:r>
+              <a:rPr sz="1700" b="0">
+                <a:solidFill>
+                  <a:srgbClr val="1E1B4B"/>
+                </a:solidFill>
+                <a:latin typeface="Calibri"/>
+              </a:rPr>
+              <a:t>Tables fail to visually highlight student strengths.</a:t>
+            </a:r>
+          </a:p>
+        </p:txBody>
+      </p:sp>
+      <p:pic>
+        <p:nvPicPr>
+          <p:cNvPr id="6" name="Picture 5" descr="slide2_comparison.png"/>
+          <p:cNvPicPr>
+            <a:picLocks noChangeAspect="1"/>
+          </p:cNvPicPr>
+          <p:nvPr/>
+        </p:nvPicPr>
+        <p:blipFill>
+          <a:blip r:embed="rId2"/>
+          <a:stretch>
+            <a:fillRect/>
+          </a:stretch>
+        </p:blipFill>
+        <p:spPr>
+          <a:xfrm>
+            <a:off x="6217920" y="1600200"/>
+            <a:ext cx="5212080" cy="3555010"/>
+          </a:xfrm>
+          <a:prstGeom prst="rect">
+            <a:avLst/>
+          </a:prstGeom>
+        </p:spPr>
+      </p:pic>
+      <p:sp>
+        <p:nvSpPr>
+          <p:cNvPr id="7" name="Rectangle 6"/>
+          <p:cNvSpPr/>
+          <p:nvPr/>
+        </p:nvSpPr>
+        <p:spPr>
+          <a:xfrm>
+            <a:off x="731520" y="6263640"/>
+            <a:ext cx="10728655" cy="18288"/>
           </a:xfrm>
           <a:prstGeom prst="rect">
             <a:avLst/>
@@ -3949,14 +4269,14 @@
       </p:sp>
       <p:sp>
         <p:nvSpPr>
-          <p:cNvPr id="5" name="TextBox 4"/>
+          <p:cNvPr id="8" name="TextBox 7"/>
           <p:cNvSpPr txBox="1"/>
           <p:nvPr/>
         </p:nvSpPr>
         <p:spPr>
           <a:xfrm>
-            <a:off x="731520" y="1645920"/>
-            <a:ext cx="10698480" cy="4572000"/>
+            <a:off x="731520" y="6327648"/>
+            <a:ext cx="10728655" cy="365760"/>
           </a:xfrm>
           <a:prstGeom prst="rect">
             <a:avLst/>
@@ -3964,178 +4284,15 @@
           <a:noFill/>
         </p:spPr>
         <p:txBody>
-          <a:bodyPr wrap="square" lIns="0" tIns="0" rIns="0" bIns="0">
-            <a:spAutoFit/>
-          </a:bodyPr>
-          <a:lstStyle/>
-          <a:p>
-            <a:pPr>
-              <a:spcBef>
-                <a:spcPts val="400"/>
-              </a:spcBef>
-              <a:spcAft>
-                <a:spcPts val="1200"/>
-              </a:spcAft>
-            </a:pPr>
-            <a:r>
-              <a:rPr sz="2000" b="1">
-                <a:solidFill>
-                  <a:srgbClr val="3B0764"/>
-                </a:solidFill>
-                <a:latin typeface="Calibri"/>
-              </a:rPr>
-              <a:t>• High Administrative Overhead: </a:t>
-            </a:r>
-            <a:r>
-              <a:rPr sz="2000" b="0">
-                <a:solidFill>
-                  <a:srgbClr val="1E1B4B"/>
-                </a:solidFill>
-                <a:latin typeface="Calibri"/>
-              </a:rPr>
-              <a:t>Manual report preparation across spreadsheets is slow and labor-intensive.</a:t>
-            </a:r>
-          </a:p>
-          <a:p>
-            <a:pPr>
-              <a:spcBef>
-                <a:spcPts val="400"/>
-              </a:spcBef>
-              <a:spcAft>
-                <a:spcPts val="1200"/>
-              </a:spcAft>
-            </a:pPr>
-            <a:r>
-              <a:rPr sz="2000" b="1">
-                <a:solidFill>
-                  <a:srgbClr val="3B0764"/>
-                </a:solidFill>
-                <a:latin typeface="Calibri"/>
-              </a:rPr>
-              <a:t>• Arithmetic Calculation Errors: </a:t>
-            </a:r>
-            <a:r>
-              <a:rPr sz="2000" b="0">
-                <a:solidFill>
-                  <a:srgbClr val="1E1B4B"/>
-                </a:solidFill>
-                <a:latin typeface="Calibri"/>
-              </a:rPr>
-              <a:t>Manual averaging and grading often produce discrepancies in student grade cards.</a:t>
-            </a:r>
-          </a:p>
-          <a:p>
-            <a:pPr>
-              <a:spcBef>
-                <a:spcPts val="400"/>
-              </a:spcBef>
-              <a:spcAft>
-                <a:spcPts val="1200"/>
-              </a:spcAft>
-            </a:pPr>
-            <a:r>
-              <a:rPr sz="2000" b="1">
-                <a:solidFill>
-                  <a:srgbClr val="3B0764"/>
-                </a:solidFill>
-                <a:latin typeface="Calibri"/>
-              </a:rPr>
-              <a:t>• Lack of Personalized Guidance: </a:t>
-            </a:r>
-            <a:r>
-              <a:rPr sz="2000" b="0">
-                <a:solidFill>
-                  <a:srgbClr val="1E1B4B"/>
-                </a:solidFill>
-                <a:latin typeface="Calibri"/>
-              </a:rPr>
-              <a:t>Standard reports only show scores, lacking individualized academic advice.</a:t>
-            </a:r>
-          </a:p>
-          <a:p>
-            <a:pPr>
-              <a:spcBef>
-                <a:spcPts val="400"/>
-              </a:spcBef>
-              <a:spcAft>
-                <a:spcPts val="1200"/>
-              </a:spcAft>
-            </a:pPr>
-            <a:r>
-              <a:rPr sz="2000" b="1">
-                <a:solidFill>
-                  <a:srgbClr val="3B0764"/>
-                </a:solidFill>
-                <a:latin typeface="Calibri"/>
-              </a:rPr>
-              <a:t>• Absent Data Visualizations: </a:t>
-            </a:r>
-            <a:r>
-              <a:rPr sz="2000" b="0">
-                <a:solidFill>
-                  <a:srgbClr val="1E1B4B"/>
-                </a:solidFill>
-                <a:latin typeface="Calibri"/>
-              </a:rPr>
-              <a:t>Tabular marks alone fail to visually communicate strengths and growth areas.</a:t>
-            </a:r>
-          </a:p>
-          <a:p>
-            <a:pPr>
-              <a:spcBef>
-                <a:spcPts val="400"/>
-              </a:spcBef>
-              <a:spcAft>
-                <a:spcPts val="1200"/>
-              </a:spcAft>
-            </a:pPr>
-            <a:r>
-              <a:rPr sz="2000" b="1">
-                <a:solidFill>
-                  <a:srgbClr val="3B0764"/>
-                </a:solidFill>
-                <a:latin typeface="Calibri"/>
-              </a:rPr>
-              <a:t>• Need for Consistent Templating: </a:t>
-            </a:r>
-            <a:r>
-              <a:rPr sz="2000" b="0">
-                <a:solidFill>
-                  <a:srgbClr val="1E1B4B"/>
-                </a:solidFill>
-                <a:latin typeface="Calibri"/>
-              </a:rPr>
-              <a:t>Institutions require unified, professional branding across all student transcripts.</a:t>
-            </a:r>
-          </a:p>
-        </p:txBody>
-      </p:sp>
-      <p:sp>
-        <p:nvSpPr>
-          <p:cNvPr id="6" name="TextBox 5"/>
-          <p:cNvSpPr txBox="1"/>
-          <p:nvPr/>
-        </p:nvSpPr>
-        <p:spPr>
-          <a:xfrm>
-            <a:off x="731520" y="6446520"/>
-            <a:ext cx="10698480" cy="320040"/>
-          </a:xfrm>
-          <a:prstGeom prst="rect">
-            <a:avLst/>
-          </a:prstGeom>
-          <a:noFill/>
-        </p:spPr>
-        <p:txBody>
           <a:bodyPr wrap="none">
             <a:spAutoFit/>
           </a:bodyPr>
           <a:lstStyle/>
           <a:p>
             <a:pPr>
-              <a:defRPr sz="1100">
-                <a:solidFill>
-                  <a:srgbClr val="6B7280"/>
+              <a:defRPr sz="1600" b="1">
+                <a:solidFill>
+                  <a:srgbClr val="6B468C"/>
                 </a:solidFill>
                 <a:latin typeface="Calibri"/>
               </a:defRPr>
@@ -4160,7 +4317,7 @@
     <p:bg>
       <p:bgPr>
         <a:solidFill>
-          <a:srgbClr val="FFFFFF"/>
+          <a:srgbClr val="FDFBFF"/>
         </a:solidFill>
         <a:effectLst/>
       </p:bgPr>
@@ -4180,8 +4337,8 @@
         </p:nvSpPr>
         <p:spPr>
           <a:xfrm>
-            <a:off x="731520" y="365760"/>
-            <a:ext cx="10698480" cy="1005840"/>
+            <a:off x="731520" y="320040"/>
+            <a:ext cx="10728655" cy="1051560"/>
           </a:xfrm>
           <a:prstGeom prst="rect">
             <a:avLst/>
@@ -4195,7 +4352,7 @@
           <a:lstStyle/>
           <a:p>
             <a:pPr>
-              <a:defRPr sz="3500" b="1">
+              <a:defRPr sz="3400" b="1">
                 <a:solidFill>
                   <a:srgbClr val="3B0764"/>
                 </a:solidFill>
@@ -4208,7 +4365,10 @@
           </a:p>
           <a:p>
             <a:pPr>
-              <a:defRPr sz="2500" b="1">
+              <a:spcBef>
+                <a:spcPts val="400"/>
+              </a:spcBef>
+              <a:defRPr sz="2200" b="1">
                 <a:solidFill>
                   <a:srgbClr val="581C87"/>
                 </a:solidFill>
@@ -4216,7 +4376,7 @@
               </a:defRPr>
             </a:pPr>
             <a:r>
-              <a:t>Automated, Decoupled Template-Driven Pipeline</a:t>
+              <a:t>Automated, Decoupled Template-Driven Academic Pipeline</a:t>
             </a:r>
           </a:p>
         </p:txBody>
@@ -4229,8 +4389,8 @@
         </p:nvSpPr>
         <p:spPr>
           <a:xfrm>
-            <a:off x="731520" y="1371600"/>
-            <a:ext cx="10698480" cy="36576"/>
+            <a:off x="731520" y="1417320"/>
+            <a:ext cx="10728655" cy="36576"/>
           </a:xfrm>
           <a:prstGeom prst="rect">
             <a:avLst/>
@@ -4268,14 +4428,218 @@
       </p:sp>
       <p:sp>
         <p:nvSpPr>
-          <p:cNvPr id="4" name="Rectangle 3"/>
+          <p:cNvPr id="4" name="Rounded Rectangle 3"/>
           <p:cNvSpPr/>
           <p:nvPr/>
         </p:nvSpPr>
         <p:spPr>
           <a:xfrm>
-            <a:off x="731520" y="6400800"/>
-            <a:ext cx="10698480" cy="18288"/>
+            <a:off x="731520" y="1600200"/>
+            <a:ext cx="5212080" cy="4480560"/>
+          </a:xfrm>
+          <a:prstGeom prst="roundRect">
+            <a:avLst/>
+          </a:prstGeom>
+          <a:solidFill>
+            <a:srgbClr val="F5F0FF"/>
+          </a:solidFill>
+          <a:ln w="19050">
+            <a:solidFill>
+              <a:srgbClr val="D8B4FE"/>
+            </a:solidFill>
+          </a:ln>
+        </p:spPr>
+        <p:style>
+          <a:lnRef idx="1">
+            <a:schemeClr val="accent1"/>
+          </a:lnRef>
+          <a:fillRef idx="3">
+            <a:schemeClr val="accent1"/>
+          </a:fillRef>
+          <a:effectRef idx="2">
+            <a:schemeClr val="accent1"/>
+          </a:effectRef>
+          <a:fontRef idx="minor">
+            <a:schemeClr val="lt1"/>
+          </a:fontRef>
+        </p:style>
+        <p:txBody>
+          <a:bodyPr rtlCol="0" anchor="ctr"/>
+          <a:lstStyle/>
+          <a:p>
+            <a:pPr algn="ctr"/>
+          </a:p>
+        </p:txBody>
+      </p:sp>
+      <p:sp>
+        <p:nvSpPr>
+          <p:cNvPr id="5" name="TextBox 4"/>
+          <p:cNvSpPr txBox="1"/>
+          <p:nvPr/>
+        </p:nvSpPr>
+        <p:spPr>
+          <a:xfrm>
+            <a:off x="960120" y="1783080"/>
+            <a:ext cx="4754880" cy="4114800"/>
+          </a:xfrm>
+          <a:prstGeom prst="rect">
+            <a:avLst/>
+          </a:prstGeom>
+          <a:noFill/>
+        </p:spPr>
+        <p:txBody>
+          <a:bodyPr wrap="square" lIns="0" tIns="0" rIns="0" bIns="0">
+            <a:spAutoFit/>
+          </a:bodyPr>
+          <a:lstStyle/>
+          <a:p>
+            <a:pPr>
+              <a:spcBef>
+                <a:spcPts val="400"/>
+              </a:spcBef>
+              <a:spcAft>
+                <a:spcPts val="1400"/>
+              </a:spcAft>
+            </a:pPr>
+            <a:r>
+              <a:rPr sz="1900" b="1">
+                <a:solidFill>
+                  <a:srgbClr val="3B0764"/>
+                </a:solidFill>
+                <a:latin typeface="Calibri"/>
+              </a:rPr>
+              <a:t>• Strict Input Validation: </a:t>
+            </a:r>
+            <a:r>
+              <a:rPr sz="1700" b="0">
+                <a:solidFill>
+                  <a:srgbClr val="1E1B4B"/>
+                </a:solidFill>
+                <a:latin typeface="Calibri"/>
+              </a:rPr>
+              <a:t>Enforces [0, 100] numerical score bounds.</a:t>
+            </a:r>
+          </a:p>
+          <a:p>
+            <a:pPr>
+              <a:spcBef>
+                <a:spcPts val="400"/>
+              </a:spcBef>
+              <a:spcAft>
+                <a:spcPts val="1400"/>
+              </a:spcAft>
+            </a:pPr>
+            <a:r>
+              <a:rPr sz="1900" b="1">
+                <a:solidFill>
+                  <a:srgbClr val="3B0764"/>
+                </a:solidFill>
+                <a:latin typeface="Calibri"/>
+              </a:rPr>
+              <a:t>• Statistical Engine: </a:t>
+            </a:r>
+            <a:r>
+              <a:rPr sz="1700" b="0">
+                <a:solidFill>
+                  <a:srgbClr val="1E1B4B"/>
+                </a:solidFill>
+                <a:latin typeface="Calibri"/>
+              </a:rPr>
+              <a:t>Automates totals, percentages, letter grades &amp; standing.</a:t>
+            </a:r>
+          </a:p>
+          <a:p>
+            <a:pPr>
+              <a:spcBef>
+                <a:spcPts val="400"/>
+              </a:spcBef>
+              <a:spcAft>
+                <a:spcPts val="1400"/>
+              </a:spcAft>
+            </a:pPr>
+            <a:r>
+              <a:rPr sz="1900" b="1">
+                <a:solidFill>
+                  <a:srgbClr val="3B0764"/>
+                </a:solidFill>
+                <a:latin typeface="Calibri"/>
+              </a:rPr>
+              <a:t>• Personalized Advice: </a:t>
+            </a:r>
+            <a:r>
+              <a:rPr sz="1700" b="0">
+                <a:solidFill>
+                  <a:srgbClr val="1E1B4B"/>
+                </a:solidFill>
+                <a:latin typeface="Calibri"/>
+              </a:rPr>
+              <a:t>Identifies top &amp; lowest courses with remedial guidance.</a:t>
+            </a:r>
+          </a:p>
+          <a:p>
+            <a:pPr>
+              <a:spcBef>
+                <a:spcPts val="400"/>
+              </a:spcBef>
+              <a:spcAft>
+                <a:spcPts val="1400"/>
+              </a:spcAft>
+            </a:pPr>
+            <a:r>
+              <a:rPr sz="1900" b="1">
+                <a:solidFill>
+                  <a:srgbClr val="3B0764"/>
+                </a:solidFill>
+                <a:latin typeface="Calibri"/>
+              </a:rPr>
+              <a:t>• Publication Output: </a:t>
+            </a:r>
+            <a:r>
+              <a:rPr sz="1700" b="0">
+                <a:solidFill>
+                  <a:srgbClr val="1E1B4B"/>
+                </a:solidFill>
+                <a:latin typeface="Calibri"/>
+              </a:rPr>
+              <a:t>Compiles vector PDF transcripts ready for print.</a:t>
+            </a:r>
+          </a:p>
+        </p:txBody>
+      </p:sp>
+      <p:pic>
+        <p:nvPicPr>
+          <p:cNvPr id="6" name="Picture 5" descr="slide3_pillars.png"/>
+          <p:cNvPicPr>
+            <a:picLocks noChangeAspect="1"/>
+          </p:cNvPicPr>
+          <p:nvPr/>
+        </p:nvPicPr>
+        <p:blipFill>
+          <a:blip r:embed="rId2"/>
+          <a:stretch>
+            <a:fillRect/>
+          </a:stretch>
+        </p:blipFill>
+        <p:spPr>
+          <a:xfrm>
+            <a:off x="6217920" y="1600200"/>
+            <a:ext cx="5212080" cy="3699188"/>
+          </a:xfrm>
+          <a:prstGeom prst="rect">
+            <a:avLst/>
+          </a:prstGeom>
+        </p:spPr>
+      </p:pic>
+      <p:sp>
+        <p:nvSpPr>
+          <p:cNvPr id="7" name="Rectangle 6"/>
+          <p:cNvSpPr/>
+          <p:nvPr/>
+        </p:nvSpPr>
+        <p:spPr>
+          <a:xfrm>
+            <a:off x="731520" y="6263640"/>
+            <a:ext cx="10728655" cy="18288"/>
           </a:xfrm>
           <a:prstGeom prst="rect">
             <a:avLst/>
@@ -4313,14 +4677,14 @@
       </p:sp>
       <p:sp>
         <p:nvSpPr>
-          <p:cNvPr id="5" name="TextBox 4"/>
+          <p:cNvPr id="8" name="TextBox 7"/>
           <p:cNvSpPr txBox="1"/>
           <p:nvPr/>
         </p:nvSpPr>
         <p:spPr>
           <a:xfrm>
-            <a:off x="731520" y="1645920"/>
-            <a:ext cx="10698480" cy="4572000"/>
+            <a:off x="731520" y="6327648"/>
+            <a:ext cx="10728655" cy="365760"/>
           </a:xfrm>
           <a:prstGeom prst="rect">
             <a:avLst/>
@@ -4328,178 +4692,15 @@
           <a:noFill/>
         </p:spPr>
         <p:txBody>
-          <a:bodyPr wrap="square" lIns="0" tIns="0" rIns="0" bIns="0">
-            <a:spAutoFit/>
-          </a:bodyPr>
-          <a:lstStyle/>
-          <a:p>
-            <a:pPr>
-              <a:spcBef>
-                <a:spcPts val="400"/>
-              </a:spcBef>
-              <a:spcAft>
-                <a:spcPts val="1200"/>
-              </a:spcAft>
-            </a:pPr>
-            <a:r>
-              <a:rPr sz="2000" b="1">
-                <a:solidFill>
-                  <a:srgbClr val="3B0764"/>
-                </a:solidFill>
-                <a:latin typeface="Calibri"/>
-              </a:rPr>
-              <a:t>• Strict Input Validation: </a:t>
-            </a:r>
-            <a:r>
-              <a:rPr sz="2000" b="0">
-                <a:solidFill>
-                  <a:srgbClr val="1E1B4B"/>
-                </a:solidFill>
-                <a:latin typeface="Calibri"/>
-              </a:rPr>
-              <a:t>Real-time boundary checks (0–100 limits, required registration fields).</a:t>
-            </a:r>
-          </a:p>
-          <a:p>
-            <a:pPr>
-              <a:spcBef>
-                <a:spcPts val="400"/>
-              </a:spcBef>
-              <a:spcAft>
-                <a:spcPts val="1200"/>
-              </a:spcAft>
-            </a:pPr>
-            <a:r>
-              <a:rPr sz="2000" b="1">
-                <a:solidFill>
-                  <a:srgbClr val="3B0764"/>
-                </a:solidFill>
-                <a:latin typeface="Calibri"/>
-              </a:rPr>
-              <a:t>• Automated Statistical Engine: </a:t>
-            </a:r>
-            <a:r>
-              <a:rPr sz="2000" b="0">
-                <a:solidFill>
-                  <a:srgbClr val="1E1B4B"/>
-                </a:solidFill>
-                <a:latin typeface="Calibri"/>
-              </a:rPr>
-              <a:t>Instant computation of totals, averages, percentages, and standing categories.</a:t>
-            </a:r>
-          </a:p>
-          <a:p>
-            <a:pPr>
-              <a:spcBef>
-                <a:spcPts val="400"/>
-              </a:spcBef>
-              <a:spcAft>
-                <a:spcPts val="1200"/>
-              </a:spcAft>
-            </a:pPr>
-            <a:r>
-              <a:rPr sz="2000" b="1">
-                <a:solidFill>
-                  <a:srgbClr val="3B0764"/>
-                </a:solidFill>
-                <a:latin typeface="Calibri"/>
-              </a:rPr>
-              <a:t>• Rule-Based Appraisal Engine: </a:t>
-            </a:r>
-            <a:r>
-              <a:rPr sz="2000" b="0">
-                <a:solidFill>
-                  <a:srgbClr val="1E1B4B"/>
-                </a:solidFill>
-                <a:latin typeface="Calibri"/>
-              </a:rPr>
-              <a:t>Generates intelligent feedback identifying top subjects and attendance warnings.</a:t>
-            </a:r>
-          </a:p>
-          <a:p>
-            <a:pPr>
-              <a:spcBef>
-                <a:spcPts val="400"/>
-              </a:spcBef>
-              <a:spcAft>
-                <a:spcPts val="1200"/>
-              </a:spcAft>
-            </a:pPr>
-            <a:r>
-              <a:rPr sz="2000" b="1">
-                <a:solidFill>
-                  <a:srgbClr val="3B0764"/>
-                </a:solidFill>
-                <a:latin typeface="Calibri"/>
-              </a:rPr>
-              <a:t>• Publication-Ready Visuals: </a:t>
-            </a:r>
-            <a:r>
-              <a:rPr sz="2000" b="0">
-                <a:solidFill>
-                  <a:srgbClr val="1E1B4B"/>
-                </a:solidFill>
-                <a:latin typeface="Calibri"/>
-              </a:rPr>
-              <a:t>Dynamic comparative bar charts highlighting benchmarks and student averages.</a:t>
-            </a:r>
-          </a:p>
-          <a:p>
-            <a:pPr>
-              <a:spcBef>
-                <a:spcPts val="400"/>
-              </a:spcBef>
-              <a:spcAft>
-                <a:spcPts val="1200"/>
-              </a:spcAft>
-            </a:pPr>
-            <a:r>
-              <a:rPr sz="2000" b="1">
-                <a:solidFill>
-                  <a:srgbClr val="3B0764"/>
-                </a:solidFill>
-                <a:latin typeface="Calibri"/>
-              </a:rPr>
-              <a:t>• Vector PDF Generation: </a:t>
-            </a:r>
-            <a:r>
-              <a:rPr sz="2000" b="0">
-                <a:solidFill>
-                  <a:srgbClr val="1E1B4B"/>
-                </a:solidFill>
-                <a:latin typeface="Calibri"/>
-              </a:rPr>
-              <a:t>ReportLab Platypus compiles print-ready academic documents on demand.</a:t>
-            </a:r>
-          </a:p>
-        </p:txBody>
-      </p:sp>
-      <p:sp>
-        <p:nvSpPr>
-          <p:cNvPr id="6" name="TextBox 5"/>
-          <p:cNvSpPr txBox="1"/>
-          <p:nvPr/>
-        </p:nvSpPr>
-        <p:spPr>
-          <a:xfrm>
-            <a:off x="731520" y="6446520"/>
-            <a:ext cx="10698480" cy="320040"/>
-          </a:xfrm>
-          <a:prstGeom prst="rect">
-            <a:avLst/>
-          </a:prstGeom>
-          <a:noFill/>
-        </p:spPr>
-        <p:txBody>
           <a:bodyPr wrap="none">
             <a:spAutoFit/>
           </a:bodyPr>
           <a:lstStyle/>
           <a:p>
             <a:pPr>
-              <a:defRPr sz="1100">
-                <a:solidFill>
-                  <a:srgbClr val="6B7280"/>
+              <a:defRPr sz="1600" b="1">
+                <a:solidFill>
+                  <a:srgbClr val="6B468C"/>
                 </a:solidFill>
                 <a:latin typeface="Calibri"/>
               </a:defRPr>
@@ -4524,7 +4725,7 @@
     <p:bg>
       <p:bgPr>
         <a:solidFill>
-          <a:srgbClr val="FFFFFF"/>
+          <a:srgbClr val="FDFBFF"/>
         </a:solidFill>
         <a:effectLst/>
       </p:bgPr>
@@ -4544,8 +4745,8 @@
         </p:nvSpPr>
         <p:spPr>
           <a:xfrm>
-            <a:off x="731520" y="365760"/>
-            <a:ext cx="10698480" cy="1005840"/>
+            <a:off x="731520" y="320040"/>
+            <a:ext cx="10728655" cy="1051560"/>
           </a:xfrm>
           <a:prstGeom prst="rect">
             <a:avLst/>
@@ -4559,7 +4760,7 @@
           <a:lstStyle/>
           <a:p>
             <a:pPr>
-              <a:defRPr sz="3500" b="1">
+              <a:defRPr sz="3400" b="1">
                 <a:solidFill>
                   <a:srgbClr val="3B0764"/>
                 </a:solidFill>
@@ -4572,7 +4773,10 @@
           </a:p>
           <a:p>
             <a:pPr>
-              <a:defRPr sz="2500" b="1">
+              <a:spcBef>
+                <a:spcPts val="400"/>
+              </a:spcBef>
+              <a:defRPr sz="2200" b="1">
                 <a:solidFill>
                   <a:srgbClr val="581C87"/>
                 </a:solidFill>
@@ -4580,7 +4784,7 @@
               </a:defRPr>
             </a:pPr>
             <a:r>
-              <a:t>4-Stage Modular Decoupled Design</a:t>
+              <a:t>4-Stage Modular Decoupled In-Memory Execution Flow</a:t>
             </a:r>
           </a:p>
         </p:txBody>
@@ -4593,8 +4797,8 @@
         </p:nvSpPr>
         <p:spPr>
           <a:xfrm>
-            <a:off x="731520" y="1371600"/>
-            <a:ext cx="10698480" cy="36576"/>
+            <a:off x="731520" y="1417320"/>
+            <a:ext cx="10728655" cy="36576"/>
           </a:xfrm>
           <a:prstGeom prst="rect">
             <a:avLst/>
@@ -4632,22 +4836,22 @@
       </p:sp>
       <p:sp>
         <p:nvSpPr>
-          <p:cNvPr id="4" name="Rectangle 3"/>
+          <p:cNvPr id="4" name="Rounded Rectangle 3"/>
           <p:cNvSpPr/>
           <p:nvPr/>
         </p:nvSpPr>
         <p:spPr>
           <a:xfrm>
-            <a:off x="731520" y="6400800"/>
-            <a:ext cx="10698480" cy="18288"/>
-          </a:xfrm>
-          <a:prstGeom prst="rect">
+            <a:off x="731520" y="1600200"/>
+            <a:ext cx="5212080" cy="4480560"/>
+          </a:xfrm>
+          <a:prstGeom prst="roundRect">
             <a:avLst/>
           </a:prstGeom>
           <a:solidFill>
-            <a:srgbClr val="D8B4FE"/>
+            <a:srgbClr val="F5F0FF"/>
           </a:solidFill>
-          <a:ln>
+          <a:ln w="19050">
             <a:solidFill>
               <a:srgbClr val="D8B4FE"/>
             </a:solidFill>
@@ -4683,8 +4887,8 @@
         </p:nvSpPr>
         <p:spPr>
           <a:xfrm>
-            <a:off x="731520" y="1600200"/>
-            <a:ext cx="5303520" cy="4572000"/>
+            <a:off x="960120" y="1783080"/>
+            <a:ext cx="4754880" cy="4114800"/>
           </a:xfrm>
           <a:prstGeom prst="rect">
             <a:avLst/>
@@ -4702,11 +4906,11 @@
                 <a:spcPts val="400"/>
               </a:spcBef>
               <a:spcAft>
-                <a:spcPts val="1200"/>
+                <a:spcPts val="1400"/>
               </a:spcAft>
             </a:pPr>
             <a:r>
-              <a:rPr sz="2000" b="1">
+              <a:rPr sz="1900" b="1">
                 <a:solidFill>
                   <a:srgbClr val="3B0764"/>
                 </a:solidFill>
@@ -4715,13 +4919,13 @@
               <a:t>• Stage 1 (Ingestion): </a:t>
             </a:r>
             <a:r>
-              <a:rPr sz="2000" b="0">
+              <a:rPr sz="1700" b="0">
                 <a:solidFill>
                   <a:srgbClr val="1E1B4B"/>
                 </a:solidFill>
                 <a:latin typeface="Calibri"/>
               </a:rPr>
-              <a:t>Streamlit UI captures student demographics &amp; 5 subject marks.</a:t>
+              <a:t>Streamlit UI collects student demographics &amp; marks.</a:t>
             </a:r>
           </a:p>
           <a:p>
@@ -4730,11 +4934,11 @@
                 <a:spcPts val="400"/>
               </a:spcBef>
               <a:spcAft>
-                <a:spcPts val="1200"/>
+                <a:spcPts val="1400"/>
               </a:spcAft>
             </a:pPr>
             <a:r>
-              <a:rPr sz="2000" b="1">
+              <a:rPr sz="1900" b="1">
                 <a:solidFill>
                   <a:srgbClr val="3B0764"/>
                 </a:solidFill>
@@ -4743,13 +4947,13 @@
               <a:t>• Stage 2 (Processing): </a:t>
             </a:r>
             <a:r>
-              <a:rPr sz="2000" b="0">
+              <a:rPr sz="1700" b="0">
                 <a:solidFill>
                   <a:srgbClr val="1E1B4B"/>
                 </a:solidFill>
                 <a:latin typeface="Calibri"/>
               </a:rPr>
-              <a:t>data_processor.py executes validation &amp; statistical aggregations.</a:t>
+              <a:t>data_processor.py executes validation &amp; calculations.</a:t>
             </a:r>
           </a:p>
           <a:p>
@@ -4758,11 +4962,11 @@
                 <a:spcPts val="400"/>
               </a:spcBef>
               <a:spcAft>
-                <a:spcPts val="1200"/>
+                <a:spcPts val="1400"/>
               </a:spcAft>
             </a:pPr>
             <a:r>
-              <a:rPr sz="2000" b="1">
+              <a:rPr sz="1900" b="1">
                 <a:solidFill>
                   <a:srgbClr val="3B0764"/>
                 </a:solidFill>
@@ -4771,13 +4975,13 @@
               <a:t>• Stage 3 (Analytics): </a:t>
             </a:r>
             <a:r>
-              <a:rPr sz="2000" b="0">
+              <a:rPr sz="1700" b="0">
                 <a:solidFill>
                   <a:srgbClr val="1E1B4B"/>
                 </a:solidFill>
                 <a:latin typeface="Calibri"/>
               </a:rPr>
-              <a:t>visualizer.py produces comparative charts via Matplotlib Agg.</a:t>
+              <a:t>visualizer.py generates comparative charts via Agg.</a:t>
             </a:r>
           </a:p>
           <a:p>
@@ -4786,11 +4990,11 @@
                 <a:spcPts val="400"/>
               </a:spcBef>
               <a:spcAft>
-                <a:spcPts val="1200"/>
+                <a:spcPts val="1400"/>
               </a:spcAft>
             </a:pPr>
             <a:r>
-              <a:rPr sz="2000" b="1">
+              <a:rPr sz="1900" b="1">
                 <a:solidFill>
                   <a:srgbClr val="3B0764"/>
                 </a:solidFill>
@@ -4799,13 +5003,13 @@
               <a:t>• Stage 4 (Compilation): </a:t>
             </a:r>
             <a:r>
-              <a:rPr sz="2000" b="0">
+              <a:rPr sz="1700" b="0">
                 <a:solidFill>
                   <a:srgbClr val="1E1B4B"/>
                 </a:solidFill>
                 <a:latin typeface="Calibri"/>
               </a:rPr>
-              <a:t>pdf_generator.py binds data into ReportLab Platypus PDF.</a:t>
+              <a:t>pdf_generator.py binds data into ReportLab Platypus.</a:t>
             </a:r>
           </a:p>
         </p:txBody>
@@ -4826,8 +5030,8 @@
         </p:blipFill>
         <p:spPr>
           <a:xfrm>
-            <a:off x="6217920" y="1691640"/>
-            <a:ext cx="5212080" cy="2441101"/>
+            <a:off x="6217920" y="1600200"/>
+            <a:ext cx="5212080" cy="3451242"/>
           </a:xfrm>
           <a:prstGeom prst="rect">
             <a:avLst/>
@@ -4836,14 +5040,59 @@
       </p:pic>
       <p:sp>
         <p:nvSpPr>
-          <p:cNvPr id="7" name="TextBox 6"/>
+          <p:cNvPr id="7" name="Rectangle 6"/>
+          <p:cNvSpPr/>
+          <p:nvPr/>
+        </p:nvSpPr>
+        <p:spPr>
+          <a:xfrm>
+            <a:off x="731520" y="6263640"/>
+            <a:ext cx="10728655" cy="18288"/>
+          </a:xfrm>
+          <a:prstGeom prst="rect">
+            <a:avLst/>
+          </a:prstGeom>
+          <a:solidFill>
+            <a:srgbClr val="D8B4FE"/>
+          </a:solidFill>
+          <a:ln>
+            <a:solidFill>
+              <a:srgbClr val="D8B4FE"/>
+            </a:solidFill>
+          </a:ln>
+        </p:spPr>
+        <p:style>
+          <a:lnRef idx="1">
+            <a:schemeClr val="accent1"/>
+          </a:lnRef>
+          <a:fillRef idx="3">
+            <a:schemeClr val="accent1"/>
+          </a:fillRef>
+          <a:effectRef idx="2">
+            <a:schemeClr val="accent1"/>
+          </a:effectRef>
+          <a:fontRef idx="minor">
+            <a:schemeClr val="lt1"/>
+          </a:fontRef>
+        </p:style>
+        <p:txBody>
+          <a:bodyPr rtlCol="0" anchor="ctr"/>
+          <a:lstStyle/>
+          <a:p>
+            <a:pPr algn="ctr"/>
+          </a:p>
+        </p:txBody>
+      </p:sp>
+      <p:sp>
+        <p:nvSpPr>
+          <p:cNvPr id="8" name="TextBox 7"/>
           <p:cNvSpPr txBox="1"/>
           <p:nvPr/>
         </p:nvSpPr>
         <p:spPr>
           <a:xfrm>
-            <a:off x="731520" y="6446520"/>
-            <a:ext cx="10698480" cy="320040"/>
+            <a:off x="731520" y="6327648"/>
+            <a:ext cx="10728655" cy="365760"/>
           </a:xfrm>
           <a:prstGeom prst="rect">
             <a:avLst/>
@@ -4857,9 +5106,9 @@
           <a:lstStyle/>
           <a:p>
             <a:pPr>
-              <a:defRPr sz="1100">
-                <a:solidFill>
-                  <a:srgbClr val="6B7280"/>
+              <a:defRPr sz="1600" b="1">
+                <a:solidFill>
+                  <a:srgbClr val="6B468C"/>
                 </a:solidFill>
                 <a:latin typeface="Calibri"/>
               </a:defRPr>
@@ -4884,7 +5133,7 @@
     <p:bg>
       <p:bgPr>
         <a:solidFill>
-          <a:srgbClr val="FFFFFF"/>
+          <a:srgbClr val="FDFBFF"/>
         </a:solidFill>
         <a:effectLst/>
       </p:bgPr>
@@ -4904,8 +5153,8 @@
         </p:nvSpPr>
         <p:spPr>
           <a:xfrm>
-            <a:off x="731520" y="365760"/>
-            <a:ext cx="10698480" cy="1005840"/>
+            <a:off x="731520" y="320040"/>
+            <a:ext cx="10728655" cy="1051560"/>
           </a:xfrm>
           <a:prstGeom prst="rect">
             <a:avLst/>
@@ -4919,7 +5168,7 @@
           <a:lstStyle/>
           <a:p>
             <a:pPr>
-              <a:defRPr sz="3500" b="1">
+              <a:defRPr sz="3400" b="1">
                 <a:solidFill>
                   <a:srgbClr val="3B0764"/>
                 </a:solidFill>
@@ -4932,7 +5181,10 @@
           </a:p>
           <a:p>
             <a:pPr>
-              <a:defRPr sz="2500" b="1">
+              <a:spcBef>
+                <a:spcPts val="400"/>
+              </a:spcBef>
+              <a:defRPr sz="2200" b="1">
                 <a:solidFill>
                   <a:srgbClr val="581C87"/>
                 </a:solidFill>
@@ -4940,7 +5192,7 @@
               </a:defRPr>
             </a:pPr>
             <a:r>
-              <a:t>100% Free, Lightweight &amp; Open-Source Stack</a:t>
+              <a:t>100% Free, Lightweight &amp; Open-Source Python Ecosystem</a:t>
             </a:r>
           </a:p>
         </p:txBody>
@@ -4953,8 +5205,8 @@
         </p:nvSpPr>
         <p:spPr>
           <a:xfrm>
-            <a:off x="731520" y="1371600"/>
-            <a:ext cx="10698480" cy="36576"/>
+            <a:off x="731520" y="1417320"/>
+            <a:ext cx="10728655" cy="36576"/>
           </a:xfrm>
           <a:prstGeom prst="rect">
             <a:avLst/>
@@ -4992,14 +5244,218 @@
       </p:sp>
       <p:sp>
         <p:nvSpPr>
-          <p:cNvPr id="4" name="Rectangle 3"/>
+          <p:cNvPr id="4" name="Rounded Rectangle 3"/>
           <p:cNvSpPr/>
           <p:nvPr/>
         </p:nvSpPr>
         <p:spPr>
           <a:xfrm>
-            <a:off x="731520" y="6400800"/>
-            <a:ext cx="10698480" cy="18288"/>
+            <a:off x="731520" y="1600200"/>
+            <a:ext cx="5212080" cy="4480560"/>
+          </a:xfrm>
+          <a:prstGeom prst="roundRect">
+            <a:avLst/>
+          </a:prstGeom>
+          <a:solidFill>
+            <a:srgbClr val="F5F0FF"/>
+          </a:solidFill>
+          <a:ln w="19050">
+            <a:solidFill>
+              <a:srgbClr val="D8B4FE"/>
+            </a:solidFill>
+          </a:ln>
+        </p:spPr>
+        <p:style>
+          <a:lnRef idx="1">
+            <a:schemeClr val="accent1"/>
+          </a:lnRef>
+          <a:fillRef idx="3">
+            <a:schemeClr val="accent1"/>
+          </a:fillRef>
+          <a:effectRef idx="2">
+            <a:schemeClr val="accent1"/>
+          </a:effectRef>
+          <a:fontRef idx="minor">
+            <a:schemeClr val="lt1"/>
+          </a:fontRef>
+        </p:style>
+        <p:txBody>
+          <a:bodyPr rtlCol="0" anchor="ctr"/>
+          <a:lstStyle/>
+          <a:p>
+            <a:pPr algn="ctr"/>
+          </a:p>
+        </p:txBody>
+      </p:sp>
+      <p:sp>
+        <p:nvSpPr>
+          <p:cNvPr id="5" name="TextBox 4"/>
+          <p:cNvSpPr txBox="1"/>
+          <p:nvPr/>
+        </p:nvSpPr>
+        <p:spPr>
+          <a:xfrm>
+            <a:off x="960120" y="1783080"/>
+            <a:ext cx="4754880" cy="4114800"/>
+          </a:xfrm>
+          <a:prstGeom prst="rect">
+            <a:avLst/>
+          </a:prstGeom>
+          <a:noFill/>
+        </p:spPr>
+        <p:txBody>
+          <a:bodyPr wrap="square" lIns="0" tIns="0" rIns="0" bIns="0">
+            <a:spAutoFit/>
+          </a:bodyPr>
+          <a:lstStyle/>
+          <a:p>
+            <a:pPr>
+              <a:spcBef>
+                <a:spcPts val="400"/>
+              </a:spcBef>
+              <a:spcAft>
+                <a:spcPts val="1400"/>
+              </a:spcAft>
+            </a:pPr>
+            <a:r>
+              <a:rPr sz="1900" b="1">
+                <a:solidFill>
+                  <a:srgbClr val="3B0764"/>
+                </a:solidFill>
+                <a:latin typeface="Calibri"/>
+              </a:rPr>
+              <a:t>• Python 3.11+: </a:t>
+            </a:r>
+            <a:r>
+              <a:rPr sz="1700" b="0">
+                <a:solidFill>
+                  <a:srgbClr val="1E1B4B"/>
+                </a:solidFill>
+                <a:latin typeface="Calibri"/>
+              </a:rPr>
+              <a:t>Core logic with strict types and in-memory io.BytesIO.</a:t>
+            </a:r>
+          </a:p>
+          <a:p>
+            <a:pPr>
+              <a:spcBef>
+                <a:spcPts val="400"/>
+              </a:spcBef>
+              <a:spcAft>
+                <a:spcPts val="1400"/>
+              </a:spcAft>
+            </a:pPr>
+            <a:r>
+              <a:rPr sz="1900" b="1">
+                <a:solidFill>
+                  <a:srgbClr val="3B0764"/>
+                </a:solidFill>
+                <a:latin typeface="Calibri"/>
+              </a:rPr>
+              <a:t>• Streamlit: </a:t>
+            </a:r>
+            <a:r>
+              <a:rPr sz="1700" b="0">
+                <a:solidFill>
+                  <a:srgbClr val="1E1B4B"/>
+                </a:solidFill>
+                <a:latin typeface="Calibri"/>
+              </a:rPr>
+              <a:t>Interactive web UI with persistent session state.</a:t>
+            </a:r>
+          </a:p>
+          <a:p>
+            <a:pPr>
+              <a:spcBef>
+                <a:spcPts val="400"/>
+              </a:spcBef>
+              <a:spcAft>
+                <a:spcPts val="1400"/>
+              </a:spcAft>
+            </a:pPr>
+            <a:r>
+              <a:rPr sz="1900" b="1">
+                <a:solidFill>
+                  <a:srgbClr val="3B0764"/>
+                </a:solidFill>
+                <a:latin typeface="Calibri"/>
+              </a:rPr>
+              <a:t>• Pandas: </a:t>
+            </a:r>
+            <a:r>
+              <a:rPr sz="1700" b="0">
+                <a:solidFill>
+                  <a:srgbClr val="1E1B4B"/>
+                </a:solidFill>
+                <a:latin typeface="Calibri"/>
+              </a:rPr>
+              <a:t>Tabular data frame structures for student records.</a:t>
+            </a:r>
+          </a:p>
+          <a:p>
+            <a:pPr>
+              <a:spcBef>
+                <a:spcPts val="400"/>
+              </a:spcBef>
+              <a:spcAft>
+                <a:spcPts val="1400"/>
+              </a:spcAft>
+            </a:pPr>
+            <a:r>
+              <a:rPr sz="1900" b="1">
+                <a:solidFill>
+                  <a:srgbClr val="3B0764"/>
+                </a:solidFill>
+                <a:latin typeface="Calibri"/>
+              </a:rPr>
+              <a:t>• ReportLab: </a:t>
+            </a:r>
+            <a:r>
+              <a:rPr sz="1700" b="0">
+                <a:solidFill>
+                  <a:srgbClr val="1E1B4B"/>
+                </a:solidFill>
+                <a:latin typeface="Calibri"/>
+              </a:rPr>
+              <a:t>Native vector PDF compilation with Flowables.</a:t>
+            </a:r>
+          </a:p>
+        </p:txBody>
+      </p:sp>
+      <p:pic>
+        <p:nvPicPr>
+          <p:cNvPr id="6" name="Picture 5" descr="slide5_tech_stack.png"/>
+          <p:cNvPicPr>
+            <a:picLocks noChangeAspect="1"/>
+          </p:cNvPicPr>
+          <p:nvPr/>
+        </p:nvPicPr>
+        <p:blipFill>
+          <a:blip r:embed="rId2"/>
+          <a:stretch>
+            <a:fillRect/>
+          </a:stretch>
+        </p:blipFill>
+        <p:spPr>
+          <a:xfrm>
+            <a:off x="6217920" y="1600200"/>
+            <a:ext cx="5212080" cy="3648456"/>
+          </a:xfrm>
+          <a:prstGeom prst="rect">
+            <a:avLst/>
+          </a:prstGeom>
+        </p:spPr>
+      </p:pic>
+      <p:sp>
+        <p:nvSpPr>
+          <p:cNvPr id="7" name="Rectangle 6"/>
+          <p:cNvSpPr/>
+          <p:nvPr/>
+        </p:nvSpPr>
+        <p:spPr>
+          <a:xfrm>
+            <a:off x="731520" y="6263640"/>
+            <a:ext cx="10728655" cy="18288"/>
           </a:xfrm>
           <a:prstGeom prst="rect">
             <a:avLst/>
@@ -5037,14 +5493,14 @@
       </p:sp>
       <p:sp>
         <p:nvSpPr>
-          <p:cNvPr id="5" name="TextBox 4"/>
+          <p:cNvPr id="8" name="TextBox 7"/>
           <p:cNvSpPr txBox="1"/>
           <p:nvPr/>
         </p:nvSpPr>
         <p:spPr>
           <a:xfrm>
-            <a:off x="731520" y="1645920"/>
-            <a:ext cx="10698480" cy="4572000"/>
+            <a:off x="731520" y="6327648"/>
+            <a:ext cx="10728655" cy="365760"/>
           </a:xfrm>
           <a:prstGeom prst="rect">
             <a:avLst/>
@@ -5052,178 +5508,15 @@
           <a:noFill/>
         </p:spPr>
         <p:txBody>
-          <a:bodyPr wrap="square" lIns="0" tIns="0" rIns="0" bIns="0">
-            <a:spAutoFit/>
-          </a:bodyPr>
-          <a:lstStyle/>
-          <a:p>
-            <a:pPr>
-              <a:spcBef>
-                <a:spcPts val="400"/>
-              </a:spcBef>
-              <a:spcAft>
-                <a:spcPts val="1200"/>
-              </a:spcAft>
-            </a:pPr>
-            <a:r>
-              <a:rPr sz="2000" b="1">
-                <a:solidFill>
-                  <a:srgbClr val="3B0764"/>
-                </a:solidFill>
-                <a:latin typeface="Calibri"/>
-              </a:rPr>
-              <a:t>• Python 3: </a:t>
-            </a:r>
-            <a:r>
-              <a:rPr sz="2000" b="0">
-                <a:solidFill>
-                  <a:srgbClr val="1E1B4B"/>
-                </a:solidFill>
-                <a:latin typeface="Calibri"/>
-              </a:rPr>
-              <a:t>Core logic, strict type hinting, and memory-efficient byte streaming (io.BytesIO).</a:t>
-            </a:r>
-          </a:p>
-          <a:p>
-            <a:pPr>
-              <a:spcBef>
-                <a:spcPts val="400"/>
-              </a:spcBef>
-              <a:spcAft>
-                <a:spcPts val="1200"/>
-              </a:spcAft>
-            </a:pPr>
-            <a:r>
-              <a:rPr sz="2000" b="1">
-                <a:solidFill>
-                  <a:srgbClr val="3B0764"/>
-                </a:solidFill>
-                <a:latin typeface="Calibri"/>
-              </a:rPr>
-              <a:t>• Streamlit: </a:t>
-            </a:r>
-            <a:r>
-              <a:rPr sz="2000" b="0">
-                <a:solidFill>
-                  <a:srgbClr val="1E1B4B"/>
-                </a:solidFill>
-                <a:latin typeface="Calibri"/>
-              </a:rPr>
-              <a:t>Reactive web interface with persistent session state management and custom CSS.</a:t>
-            </a:r>
-          </a:p>
-          <a:p>
-            <a:pPr>
-              <a:spcBef>
-                <a:spcPts val="400"/>
-              </a:spcBef>
-              <a:spcAft>
-                <a:spcPts val="1200"/>
-              </a:spcAft>
-            </a:pPr>
-            <a:r>
-              <a:rPr sz="2000" b="1">
-                <a:solidFill>
-                  <a:srgbClr val="3B0764"/>
-                </a:solidFill>
-                <a:latin typeface="Calibri"/>
-              </a:rPr>
-              <a:t>• Pandas: </a:t>
-            </a:r>
-            <a:r>
-              <a:rPr sz="2000" b="0">
-                <a:solidFill>
-                  <a:srgbClr val="1E1B4B"/>
-                </a:solidFill>
-                <a:latin typeface="Calibri"/>
-              </a:rPr>
-              <a:t>Tabular data frame structures for structured academic record manipulation.</a:t>
-            </a:r>
-          </a:p>
-          <a:p>
-            <a:pPr>
-              <a:spcBef>
-                <a:spcPts val="400"/>
-              </a:spcBef>
-              <a:spcAft>
-                <a:spcPts val="1200"/>
-              </a:spcAft>
-            </a:pPr>
-            <a:r>
-              <a:rPr sz="2000" b="1">
-                <a:solidFill>
-                  <a:srgbClr val="3B0764"/>
-                </a:solidFill>
-                <a:latin typeface="Calibri"/>
-              </a:rPr>
-              <a:t>• Matplotlib (Agg): </a:t>
-            </a:r>
-            <a:r>
-              <a:rPr sz="2000" b="0">
-                <a:solidFill>
-                  <a:srgbClr val="1E1B4B"/>
-                </a:solidFill>
-                <a:latin typeface="Calibri"/>
-              </a:rPr>
-              <a:t>Headless, thread-safe charting that prevents GUI backend threading crashes.</a:t>
-            </a:r>
-          </a:p>
-          <a:p>
-            <a:pPr>
-              <a:spcBef>
-                <a:spcPts val="400"/>
-              </a:spcBef>
-              <a:spcAft>
-                <a:spcPts val="1200"/>
-              </a:spcAft>
-            </a:pPr>
-            <a:r>
-              <a:rPr sz="2000" b="1">
-                <a:solidFill>
-                  <a:srgbClr val="3B0764"/>
-                </a:solidFill>
-                <a:latin typeface="Calibri"/>
-              </a:rPr>
-              <a:t>• ReportLab Platypus: </a:t>
-            </a:r>
-            <a:r>
-              <a:rPr sz="2000" b="0">
-                <a:solidFill>
-                  <a:srgbClr val="1E1B4B"/>
-                </a:solidFill>
-                <a:latin typeface="Calibri"/>
-              </a:rPr>
-              <a:t>Native vector PDF compilation with tables and flowables (no external OS tools).</a:t>
-            </a:r>
-          </a:p>
-        </p:txBody>
-      </p:sp>
-      <p:sp>
-        <p:nvSpPr>
-          <p:cNvPr id="6" name="TextBox 5"/>
-          <p:cNvSpPr txBox="1"/>
-          <p:nvPr/>
-        </p:nvSpPr>
-        <p:spPr>
-          <a:xfrm>
-            <a:off x="731520" y="6446520"/>
-            <a:ext cx="10698480" cy="320040"/>
-          </a:xfrm>
-          <a:prstGeom prst="rect">
-            <a:avLst/>
-          </a:prstGeom>
-          <a:noFill/>
-        </p:spPr>
-        <p:txBody>
           <a:bodyPr wrap="none">
             <a:spAutoFit/>
           </a:bodyPr>
           <a:lstStyle/>
           <a:p>
             <a:pPr>
-              <a:defRPr sz="1100">
-                <a:solidFill>
-                  <a:srgbClr val="6B7280"/>
+              <a:defRPr sz="1600" b="1">
+                <a:solidFill>
+                  <a:srgbClr val="6B468C"/>
                 </a:solidFill>
                 <a:latin typeface="Calibri"/>
               </a:defRPr>
@@ -5248,7 +5541,7 @@
     <p:bg>
       <p:bgPr>
         <a:solidFill>
-          <a:srgbClr val="FFFFFF"/>
+          <a:srgbClr val="FDFBFF"/>
         </a:solidFill>
         <a:effectLst/>
       </p:bgPr>
@@ -5268,8 +5561,8 @@
         </p:nvSpPr>
         <p:spPr>
           <a:xfrm>
-            <a:off x="731520" y="365760"/>
-            <a:ext cx="10698480" cy="1005840"/>
+            <a:off x="731520" y="320040"/>
+            <a:ext cx="10728655" cy="1051560"/>
           </a:xfrm>
           <a:prstGeom prst="rect">
             <a:avLst/>
@@ -5283,7 +5576,7 @@
           <a:lstStyle/>
           <a:p>
             <a:pPr>
-              <a:defRPr sz="3500" b="1">
+              <a:defRPr sz="3400" b="1">
                 <a:solidFill>
                   <a:srgbClr val="3B0764"/>
                 </a:solidFill>
@@ -5296,7 +5589,10 @@
           </a:p>
           <a:p>
             <a:pPr>
-              <a:defRPr sz="2500" b="1">
+              <a:spcBef>
+                <a:spcPts val="400"/>
+              </a:spcBef>
+              <a:defRPr sz="2200" b="1">
                 <a:solidFill>
                   <a:srgbClr val="581C87"/>
                 </a:solidFill>
@@ -5304,7 +5600,7 @@
               </a:defRPr>
             </a:pPr>
             <a:r>
-              <a:t>Clearly Defined Academic Thresholds &amp; Constraints</a:t>
+              <a:t>Clearly Defined University Evaluation Thresholds</a:t>
             </a:r>
           </a:p>
         </p:txBody>
@@ -5317,8 +5613,8 @@
         </p:nvSpPr>
         <p:spPr>
           <a:xfrm>
-            <a:off x="731520" y="1371600"/>
-            <a:ext cx="10698480" cy="36576"/>
+            <a:off x="731520" y="1417320"/>
+            <a:ext cx="10728655" cy="36576"/>
           </a:xfrm>
           <a:prstGeom prst="rect">
             <a:avLst/>
@@ -5356,22 +5652,22 @@
       </p:sp>
       <p:sp>
         <p:nvSpPr>
-          <p:cNvPr id="4" name="Rectangle 3"/>
+          <p:cNvPr id="4" name="Rounded Rectangle 3"/>
           <p:cNvSpPr/>
           <p:nvPr/>
         </p:nvSpPr>
         <p:spPr>
           <a:xfrm>
-            <a:off x="731520" y="6400800"/>
-            <a:ext cx="10698480" cy="18288"/>
-          </a:xfrm>
-          <a:prstGeom prst="rect">
+            <a:off x="731520" y="1600200"/>
+            <a:ext cx="5212080" cy="4480560"/>
+          </a:xfrm>
+          <a:prstGeom prst="roundRect">
             <a:avLst/>
           </a:prstGeom>
           <a:solidFill>
-            <a:srgbClr val="D8B4FE"/>
+            <a:srgbClr val="F5F0FF"/>
           </a:solidFill>
-          <a:ln>
+          <a:ln w="19050">
             <a:solidFill>
               <a:srgbClr val="D8B4FE"/>
             </a:solidFill>
@@ -5407,8 +5703,8 @@
         </p:nvSpPr>
         <p:spPr>
           <a:xfrm>
-            <a:off x="731520" y="1600200"/>
-            <a:ext cx="5303520" cy="4572000"/>
+            <a:off x="960120" y="1783080"/>
+            <a:ext cx="4754880" cy="4114800"/>
           </a:xfrm>
           <a:prstGeom prst="rect">
             <a:avLst/>
@@ -5426,26 +5722,26 @@
                 <a:spcPts val="400"/>
               </a:spcBef>
               <a:spcAft>
-                <a:spcPts val="1200"/>
+                <a:spcPts val="1400"/>
               </a:spcAft>
             </a:pPr>
             <a:r>
-              <a:rPr sz="2000" b="1">
+              <a:rPr sz="1900" b="1">
                 <a:solidFill>
                   <a:srgbClr val="3B0764"/>
                 </a:solidFill>
                 <a:latin typeface="Calibri"/>
               </a:rPr>
-              <a:t>• Boundary Enforcement: </a:t>
-            </a:r>
-            <a:r>
-              <a:rPr sz="2000" b="0">
+              <a:t>• Boundary Checks: </a:t>
+            </a:r>
+            <a:r>
+              <a:rPr sz="1700" b="0">
                 <a:solidFill>
                   <a:srgbClr val="1E1B4B"/>
                 </a:solidFill>
                 <a:latin typeface="Calibri"/>
               </a:rPr>
-              <a:t>Name &amp; Roll required; marks &amp; attendance strictly in [0, 100].</a:t>
+              <a:t>Name/Roll required; marks &amp; attendance strictly in [0, 100].</a:t>
             </a:r>
           </a:p>
           <a:p>
@@ -5454,20 +5750,20 @@
                 <a:spcPts val="400"/>
               </a:spcBef>
               <a:spcAft>
-                <a:spcPts val="1200"/>
+                <a:spcPts val="1400"/>
               </a:spcAft>
             </a:pPr>
             <a:r>
-              <a:rPr sz="2000" b="1">
+              <a:rPr sz="1900" b="1">
                 <a:solidFill>
                   <a:srgbClr val="3B0764"/>
                 </a:solidFill>
                 <a:latin typeface="Calibri"/>
               </a:rPr>
-              <a:t>• Four Academic Tiers: </a:t>
-            </a:r>
-            <a:r>
-              <a:rPr sz="2000" b="0">
+              <a:t>• 4 Standing Tiers: </a:t>
+            </a:r>
+            <a:r>
+              <a:rPr sz="1700" b="0">
                 <a:solidFill>
                   <a:srgbClr val="1E1B4B"/>
                 </a:solidFill>
@@ -5482,26 +5778,26 @@
                 <a:spcPts val="400"/>
               </a:spcBef>
               <a:spcAft>
-                <a:spcPts val="1200"/>
+                <a:spcPts val="1400"/>
               </a:spcAft>
             </a:pPr>
             <a:r>
-              <a:rPr sz="2000" b="1">
+              <a:rPr sz="1900" b="1">
                 <a:solidFill>
                   <a:srgbClr val="3B0764"/>
                 </a:solidFill>
                 <a:latin typeface="Calibri"/>
               </a:rPr>
-              <a:t>• Attendance Compliance: </a:t>
-            </a:r>
-            <a:r>
-              <a:rPr sz="2000" b="0">
+              <a:t>• Attendance Norms: </a:t>
+            </a:r>
+            <a:r>
+              <a:rPr sz="1700" b="0">
                 <a:solidFill>
                   <a:srgbClr val="1E1B4B"/>
                 </a:solidFill>
                 <a:latin typeface="Calibri"/>
               </a:rPr>
-              <a:t>Standard &gt;= 75% required; &lt; 75% triggers an immediate Shortage Alert.</a:t>
+              <a:t>Standard &gt;= 75% required; &lt; 75% triggers shortage alert.</a:t>
             </a:r>
           </a:p>
           <a:p>
@@ -5510,26 +5806,26 @@
                 <a:spcPts val="400"/>
               </a:spcBef>
               <a:spcAft>
-                <a:spcPts val="1200"/>
+                <a:spcPts val="1400"/>
               </a:spcAft>
             </a:pPr>
             <a:r>
-              <a:rPr sz="2000" b="1">
+              <a:rPr sz="1900" b="1">
                 <a:solidFill>
                   <a:srgbClr val="3B0764"/>
                 </a:solidFill>
                 <a:latin typeface="Calibri"/>
               </a:rPr>
-              <a:t>• Multi-Factor Feedback: </a:t>
-            </a:r>
-            <a:r>
-              <a:rPr sz="2000" b="0">
+              <a:t>• Remedial Engine: </a:t>
+            </a:r>
+            <a:r>
+              <a:rPr sz="1700" b="0">
                 <a:solidFill>
                   <a:srgbClr val="1E1B4B"/>
                 </a:solidFill>
                 <a:latin typeface="Calibri"/>
               </a:rPr>
-              <a:t>Praises highest subject while highlighting targeted areas for growth.</a:t>
+              <a:t>Praises strengths and recommends corrective actions.</a:t>
             </a:r>
           </a:p>
         </p:txBody>
@@ -5550,8 +5846,8 @@
         </p:blipFill>
         <p:spPr>
           <a:xfrm>
-            <a:off x="6217920" y="1691640"/>
-            <a:ext cx="5212080" cy="2606040"/>
+            <a:off x="6217920" y="1600200"/>
+            <a:ext cx="5212080" cy="3369287"/>
           </a:xfrm>
           <a:prstGeom prst="rect">
             <a:avLst/>
@@ -5560,14 +5856,59 @@
       </p:pic>
       <p:sp>
         <p:nvSpPr>
-          <p:cNvPr id="7" name="TextBox 6"/>
+          <p:cNvPr id="7" name="Rectangle 6"/>
+          <p:cNvSpPr/>
+          <p:nvPr/>
+        </p:nvSpPr>
+        <p:spPr>
+          <a:xfrm>
+            <a:off x="731520" y="6263640"/>
+            <a:ext cx="10728655" cy="18288"/>
+          </a:xfrm>
+          <a:prstGeom prst="rect">
+            <a:avLst/>
+          </a:prstGeom>
+          <a:solidFill>
+            <a:srgbClr val="D8B4FE"/>
+          </a:solidFill>
+          <a:ln>
+            <a:solidFill>
+              <a:srgbClr val="D8B4FE"/>
+            </a:solidFill>
+          </a:ln>
+        </p:spPr>
+        <p:style>
+          <a:lnRef idx="1">
+            <a:schemeClr val="accent1"/>
+          </a:lnRef>
+          <a:fillRef idx="3">
+            <a:schemeClr val="accent1"/>
+          </a:fillRef>
+          <a:effectRef idx="2">
+            <a:schemeClr val="accent1"/>
+          </a:effectRef>
+          <a:fontRef idx="minor">
+            <a:schemeClr val="lt1"/>
+          </a:fontRef>
+        </p:style>
+        <p:txBody>
+          <a:bodyPr rtlCol="0" anchor="ctr"/>
+          <a:lstStyle/>
+          <a:p>
+            <a:pPr algn="ctr"/>
+          </a:p>
+        </p:txBody>
+      </p:sp>
+      <p:sp>
+        <p:nvSpPr>
+          <p:cNvPr id="8" name="TextBox 7"/>
           <p:cNvSpPr txBox="1"/>
           <p:nvPr/>
         </p:nvSpPr>
         <p:spPr>
           <a:xfrm>
-            <a:off x="731520" y="6446520"/>
-            <a:ext cx="10698480" cy="320040"/>
+            <a:off x="731520" y="6327648"/>
+            <a:ext cx="10728655" cy="365760"/>
           </a:xfrm>
           <a:prstGeom prst="rect">
             <a:avLst/>
@@ -5581,9 +5922,9 @@
           <a:lstStyle/>
           <a:p>
             <a:pPr>
-              <a:defRPr sz="1100">
-                <a:solidFill>
-                  <a:srgbClr val="6B7280"/>
+              <a:defRPr sz="1600" b="1">
+                <a:solidFill>
+                  <a:srgbClr val="6B468C"/>
                 </a:solidFill>
                 <a:latin typeface="Calibri"/>
               </a:defRPr>
@@ -5608,7 +5949,7 @@
     <p:bg>
       <p:bgPr>
         <a:solidFill>
-          <a:srgbClr val="FFFFFF"/>
+          <a:srgbClr val="FDFBFF"/>
         </a:solidFill>
         <a:effectLst/>
       </p:bgPr>
@@ -5628,8 +5969,8 @@
         </p:nvSpPr>
         <p:spPr>
           <a:xfrm>
-            <a:off x="731520" y="365760"/>
-            <a:ext cx="10698480" cy="1005840"/>
+            <a:off x="731520" y="320040"/>
+            <a:ext cx="10728655" cy="1051560"/>
           </a:xfrm>
           <a:prstGeom prst="rect">
             <a:avLst/>
@@ -5643,7 +5984,7 @@
           <a:lstStyle/>
           <a:p>
             <a:pPr>
-              <a:defRPr sz="3500" b="1">
+              <a:defRPr sz="3400" b="1">
                 <a:solidFill>
                   <a:srgbClr val="3B0764"/>
                 </a:solidFill>
@@ -5656,7 +5997,10 @@
           </a:p>
           <a:p>
             <a:pPr>
-              <a:defRPr sz="2500" b="1">
+              <a:spcBef>
+                <a:spcPts val="400"/>
+              </a:spcBef>
+              <a:defRPr sz="2200" b="1">
                 <a:solidFill>
                   <a:srgbClr val="581C87"/>
                 </a:solidFill>
@@ -5664,7 +6008,7 @@
               </a:defRPr>
             </a:pPr>
             <a:r>
-              <a:t>In-Memory Academic Performance Analytics</a:t>
+              <a:t>Comparative Academic Performance Visual Analytics</a:t>
             </a:r>
           </a:p>
         </p:txBody>
@@ -5677,8 +6021,8 @@
         </p:nvSpPr>
         <p:spPr>
           <a:xfrm>
-            <a:off x="731520" y="1371600"/>
-            <a:ext cx="10698480" cy="36576"/>
+            <a:off x="731520" y="1417320"/>
+            <a:ext cx="10728655" cy="36576"/>
           </a:xfrm>
           <a:prstGeom prst="rect">
             <a:avLst/>
@@ -5716,22 +6060,22 @@
       </p:sp>
       <p:sp>
         <p:nvSpPr>
-          <p:cNvPr id="4" name="Rectangle 3"/>
+          <p:cNvPr id="4" name="Rounded Rectangle 3"/>
           <p:cNvSpPr/>
           <p:nvPr/>
         </p:nvSpPr>
         <p:spPr>
           <a:xfrm>
-            <a:off x="731520" y="6400800"/>
-            <a:ext cx="10698480" cy="18288"/>
-          </a:xfrm>
-          <a:prstGeom prst="rect">
+            <a:off x="731520" y="1600200"/>
+            <a:ext cx="5212080" cy="4480560"/>
+          </a:xfrm>
+          <a:prstGeom prst="roundRect">
             <a:avLst/>
           </a:prstGeom>
           <a:solidFill>
-            <a:srgbClr val="D8B4FE"/>
+            <a:srgbClr val="F5F0FF"/>
           </a:solidFill>
-          <a:ln>
+          <a:ln w="19050">
             <a:solidFill>
               <a:srgbClr val="D8B4FE"/>
             </a:solidFill>
@@ -5767,8 +6111,8 @@
         </p:nvSpPr>
         <p:spPr>
           <a:xfrm>
-            <a:off x="731520" y="1600200"/>
-            <a:ext cx="5303520" cy="4572000"/>
+            <a:off x="960120" y="1783080"/>
+            <a:ext cx="4754880" cy="4114800"/>
           </a:xfrm>
           <a:prstGeom prst="rect">
             <a:avLst/>
@@ -5786,26 +6130,26 @@
                 <a:spcPts val="400"/>
               </a:spcBef>
               <a:spcAft>
-                <a:spcPts val="1200"/>
+                <a:spcPts val="1400"/>
               </a:spcAft>
             </a:pPr>
             <a:r>
-              <a:rPr sz="2000" b="1">
+              <a:rPr sz="1900" b="1">
                 <a:solidFill>
                   <a:srgbClr val="3B0764"/>
                 </a:solidFill>
                 <a:latin typeface="Calibri"/>
               </a:rPr>
-              <a:t>• Dynamic Bar Palette: </a:t>
-            </a:r>
-            <a:r>
-              <a:rPr sz="2000" b="0">
+              <a:t>• Tier Color Coding: </a:t>
+            </a:r>
+            <a:r>
+              <a:rPr sz="1700" b="0">
                 <a:solidFill>
                   <a:srgbClr val="1E1B4B"/>
                 </a:solidFill>
                 <a:latin typeface="Calibri"/>
               </a:rPr>
-              <a:t>Scores color-coded based on performance tiers for instant clarity.</a:t>
+              <a:t>Bars styled according to performance category.</a:t>
             </a:r>
           </a:p>
           <a:p>
@@ -5814,26 +6158,26 @@
                 <a:spcPts val="400"/>
               </a:spcBef>
               <a:spcAft>
-                <a:spcPts val="1200"/>
+                <a:spcPts val="1400"/>
               </a:spcAft>
             </a:pPr>
             <a:r>
-              <a:rPr sz="2000" b="1">
+              <a:rPr sz="1900" b="1">
                 <a:solidFill>
                   <a:srgbClr val="3B0764"/>
                 </a:solidFill>
                 <a:latin typeface="Calibri"/>
               </a:rPr>
-              <a:t>• Benchmark Reference Lines: </a:t>
-            </a:r>
-            <a:r>
-              <a:rPr sz="2000" b="0">
+              <a:t>• Benchmark Lines: </a:t>
+            </a:r>
+            <a:r>
+              <a:rPr sz="1700" b="0">
                 <a:solidFill>
                   <a:srgbClr val="1E1B4B"/>
                 </a:solidFill>
                 <a:latin typeface="Calibri"/>
               </a:rPr>
-              <a:t>Passing mark threshold (50) and dynamic student average line.</a:t>
+              <a:t>Visual pass benchmark (50) and student aggregate line.</a:t>
             </a:r>
           </a:p>
           <a:p>
@@ -5842,26 +6186,26 @@
                 <a:spcPts val="400"/>
               </a:spcBef>
               <a:spcAft>
-                <a:spcPts val="1200"/>
+                <a:spcPts val="1400"/>
               </a:spcAft>
             </a:pPr>
             <a:r>
-              <a:rPr sz="2000" b="1">
+              <a:rPr sz="1900" b="1">
                 <a:solidFill>
                   <a:srgbClr val="3B0764"/>
                 </a:solidFill>
                 <a:latin typeface="Calibri"/>
               </a:rPr>
-              <a:t>• Value Annotations: </a:t>
-            </a:r>
-            <a:r>
-              <a:rPr sz="2000" b="0">
+              <a:t>• Score Annotations: </a:t>
+            </a:r>
+            <a:r>
+              <a:rPr sz="1700" b="0">
                 <a:solidFill>
                   <a:srgbClr val="1E1B4B"/>
                 </a:solidFill>
                 <a:latin typeface="Calibri"/>
               </a:rPr>
-              <a:t>Numerical scores explicitly annotated above each bar for readability.</a:t>
+              <a:t>Numerical marks annotated on top of each bar.</a:t>
             </a:r>
           </a:p>
           <a:p>
@@ -5870,26 +6214,26 @@
                 <a:spcPts val="400"/>
               </a:spcBef>
               <a:spcAft>
-                <a:spcPts val="1200"/>
+                <a:spcPts val="1400"/>
               </a:spcAft>
             </a:pPr>
             <a:r>
-              <a:rPr sz="2000" b="1">
+              <a:rPr sz="1900" b="1">
                 <a:solidFill>
                   <a:srgbClr val="3B0764"/>
                 </a:solidFill>
                 <a:latin typeface="Calibri"/>
               </a:rPr>
-              <a:t>• Zero-Disk Byte Buffering: </a:t>
-            </a:r>
-            <a:r>
-              <a:rPr sz="2000" b="0">
+              <a:t>• Zero Disk I/O: </a:t>
+            </a:r>
+            <a:r>
+              <a:rPr sz="1700" b="0">
                 <a:solidFill>
                   <a:srgbClr val="1E1B4B"/>
                 </a:solidFill>
                 <a:latin typeface="Calibri"/>
               </a:rPr>
-              <a:t>Chart rasterized directly to io.BytesIO for web &amp; PDF embedding.</a:t>
+              <a:t>Charts rasterized to in-memory bytes for immediate PDF embed.</a:t>
             </a:r>
           </a:p>
         </p:txBody>
@@ -5910,8 +6254,8 @@
         </p:blipFill>
         <p:spPr>
           <a:xfrm>
-            <a:off x="6217920" y="1691640"/>
-            <a:ext cx="5212080" cy="2606040"/>
+            <a:off x="6217920" y="1600200"/>
+            <a:ext cx="5212080" cy="3310375"/>
           </a:xfrm>
           <a:prstGeom prst="rect">
             <a:avLst/>
@@ -5920,14 +6264,59 @@
       </p:pic>
       <p:sp>
         <p:nvSpPr>
-          <p:cNvPr id="7" name="TextBox 6"/>
+          <p:cNvPr id="7" name="Rectangle 6"/>
+          <p:cNvSpPr/>
+          <p:nvPr/>
+        </p:nvSpPr>
+        <p:spPr>
+          <a:xfrm>
+            <a:off x="731520" y="6263640"/>
+            <a:ext cx="10728655" cy="18288"/>
+          </a:xfrm>
+          <a:prstGeom prst="rect">
+            <a:avLst/>
+          </a:prstGeom>
+          <a:solidFill>
+            <a:srgbClr val="D8B4FE"/>
+          </a:solidFill>
+          <a:ln>
+            <a:solidFill>
+              <a:srgbClr val="D8B4FE"/>
+            </a:solidFill>
+          </a:ln>
+        </p:spPr>
+        <p:style>
+          <a:lnRef idx="1">
+            <a:schemeClr val="accent1"/>
+          </a:lnRef>
+          <a:fillRef idx="3">
+            <a:schemeClr val="accent1"/>
+          </a:fillRef>
+          <a:effectRef idx="2">
+            <a:schemeClr val="accent1"/>
+          </a:effectRef>
+          <a:fontRef idx="minor">
+            <a:schemeClr val="lt1"/>
+          </a:fontRef>
+        </p:style>
+        <p:txBody>
+          <a:bodyPr rtlCol="0" anchor="ctr"/>
+          <a:lstStyle/>
+          <a:p>
+            <a:pPr algn="ctr"/>
+          </a:p>
+        </p:txBody>
+      </p:sp>
+      <p:sp>
+        <p:nvSpPr>
+          <p:cNvPr id="8" name="TextBox 7"/>
           <p:cNvSpPr txBox="1"/>
           <p:nvPr/>
         </p:nvSpPr>
         <p:spPr>
           <a:xfrm>
-            <a:off x="731520" y="6446520"/>
-            <a:ext cx="10698480" cy="320040"/>
+            <a:off x="731520" y="6327648"/>
+            <a:ext cx="10728655" cy="365760"/>
           </a:xfrm>
           <a:prstGeom prst="rect">
             <a:avLst/>
@@ -5941,9 +6330,9 @@
           <a:lstStyle/>
           <a:p>
             <a:pPr>
-              <a:defRPr sz="1100">
-                <a:solidFill>
-                  <a:srgbClr val="6B7280"/>
+              <a:defRPr sz="1600" b="1">
+                <a:solidFill>
+                  <a:srgbClr val="6B468C"/>
                 </a:solidFill>
                 <a:latin typeface="Calibri"/>
               </a:defRPr>
@@ -5968,7 +6357,7 @@
     <p:bg>
       <p:bgPr>
         <a:solidFill>
-          <a:srgbClr val="FFFFFF"/>
+          <a:srgbClr val="FDFBFF"/>
         </a:solidFill>
         <a:effectLst/>
       </p:bgPr>
@@ -5988,8 +6377,8 @@
         </p:nvSpPr>
         <p:spPr>
           <a:xfrm>
-            <a:off x="731520" y="365760"/>
-            <a:ext cx="10698480" cy="1005840"/>
+            <a:off x="731520" y="320040"/>
+            <a:ext cx="10728655" cy="1051560"/>
           </a:xfrm>
           <a:prstGeom prst="rect">
             <a:avLst/>
@@ -6003,7 +6392,7 @@
           <a:lstStyle/>
           <a:p>
             <a:pPr>
-              <a:defRPr sz="3500" b="1">
+              <a:defRPr sz="3400" b="1">
                 <a:solidFill>
                   <a:srgbClr val="3B0764"/>
                 </a:solidFill>
@@ -6016,7 +6405,10 @@
           </a:p>
           <a:p>
             <a:pPr>
-              <a:defRPr sz="2500" b="1">
+              <a:spcBef>
+                <a:spcPts val="400"/>
+              </a:spcBef>
+              <a:defRPr sz="2200" b="1">
                 <a:solidFill>
                   <a:srgbClr val="581C87"/>
                 </a:solidFill>
@@ -6024,7 +6416,7 @@
               </a:defRPr>
             </a:pPr>
             <a:r>
-              <a:t>Reusable Document Layout via ReportLab Platypus</a:t>
+              <a:t>Printable Academic Transcripts via ReportLab Platypus</a:t>
             </a:r>
           </a:p>
         </p:txBody>
@@ -6037,8 +6429,8 @@
         </p:nvSpPr>
         <p:spPr>
           <a:xfrm>
-            <a:off x="731520" y="1371600"/>
-            <a:ext cx="10698480" cy="36576"/>
+            <a:off x="731520" y="1417320"/>
+            <a:ext cx="10728655" cy="36576"/>
           </a:xfrm>
           <a:prstGeom prst="rect">
             <a:avLst/>
@@ -6076,22 +6468,22 @@
       </p:sp>
       <p:sp>
         <p:nvSpPr>
-          <p:cNvPr id="4" name="Rectangle 3"/>
+          <p:cNvPr id="4" name="Rounded Rectangle 3"/>
           <p:cNvSpPr/>
           <p:nvPr/>
         </p:nvSpPr>
         <p:spPr>
           <a:xfrm>
-            <a:off x="731520" y="6400800"/>
-            <a:ext cx="10698480" cy="18288"/>
-          </a:xfrm>
-          <a:prstGeom prst="rect">
+            <a:off x="731520" y="1600200"/>
+            <a:ext cx="5212080" cy="4480560"/>
+          </a:xfrm>
+          <a:prstGeom prst="roundRect">
             <a:avLst/>
           </a:prstGeom>
           <a:solidFill>
-            <a:srgbClr val="D8B4FE"/>
+            <a:srgbClr val="F5F0FF"/>
           </a:solidFill>
-          <a:ln>
+          <a:ln w="19050">
             <a:solidFill>
               <a:srgbClr val="D8B4FE"/>
             </a:solidFill>
@@ -6127,8 +6519,8 @@
         </p:nvSpPr>
         <p:spPr>
           <a:xfrm>
-            <a:off x="731520" y="1600200"/>
-            <a:ext cx="5303520" cy="4572000"/>
+            <a:off x="960120" y="1783080"/>
+            <a:ext cx="4754880" cy="4114800"/>
           </a:xfrm>
           <a:prstGeom prst="rect">
             <a:avLst/>
@@ -6146,26 +6538,26 @@
                 <a:spcPts val="400"/>
               </a:spcBef>
               <a:spcAft>
-                <a:spcPts val="1200"/>
+                <a:spcPts val="1400"/>
               </a:spcAft>
             </a:pPr>
             <a:r>
-              <a:rPr sz="2000" b="1">
+              <a:rPr sz="1900" b="1">
                 <a:solidFill>
                   <a:srgbClr val="3B0764"/>
                 </a:solidFill>
                 <a:latin typeface="Calibri"/>
               </a:rPr>
-              <a:t>• Decoupled Architecture: </a:t>
-            </a:r>
-            <a:r>
-              <a:rPr sz="2000" b="0">
+              <a:t>• Template Decoupling: </a:t>
+            </a:r>
+            <a:r>
+              <a:rPr sz="1700" b="0">
                 <a:solidFill>
                   <a:srgbClr val="1E1B4B"/>
                 </a:solidFill>
                 <a:latin typeface="Calibri"/>
               </a:rPr>
-              <a:t>Layout geometry remains static while dynamic student data is injected.</a:t>
+              <a:t>Static visual geometry separated from dynamic student data.</a:t>
             </a:r>
           </a:p>
           <a:p>
@@ -6174,11 +6566,11 @@
                 <a:spcPts val="400"/>
               </a:spcBef>
               <a:spcAft>
-                <a:spcPts val="1200"/>
+                <a:spcPts val="1400"/>
               </a:spcAft>
             </a:pPr>
             <a:r>
-              <a:rPr sz="2000" b="1">
+              <a:rPr sz="1900" b="1">
                 <a:solidFill>
                   <a:srgbClr val="3B0764"/>
                 </a:solidFill>
@@ -6187,13 +6579,13 @@
               <a:t>• Platypus Flowables: </a:t>
             </a:r>
             <a:r>
-              <a:rPr sz="2000" b="0">
+              <a:rPr sz="1700" b="0">
                 <a:solidFill>
                   <a:srgbClr val="1E1B4B"/>
                 </a:solidFill>
                 <a:latin typeface="Calibri"/>
               </a:rPr>
-              <a:t>Uses Paragraphs, Tables, and KeepTogether to prevent page overflows.</a:t>
+              <a:t>Automatic page budget management and clean pagination.</a:t>
             </a:r>
           </a:p>
           <a:p>
@@ -6202,26 +6594,26 @@
                 <a:spcPts val="400"/>
               </a:spcBef>
               <a:spcAft>
-                <a:spcPts val="1200"/>
+                <a:spcPts val="1400"/>
               </a:spcAft>
             </a:pPr>
             <a:r>
-              <a:rPr sz="2000" b="1">
+              <a:rPr sz="1900" b="1">
                 <a:solidFill>
                   <a:srgbClr val="3B0764"/>
                 </a:solidFill>
                 <a:latin typeface="Calibri"/>
               </a:rPr>
-              <a:t>• Institutional Elements: </a:t>
-            </a:r>
-            <a:r>
-              <a:rPr sz="2000" b="0">
+              <a:t>• Official Elements: </a:t>
+            </a:r>
+            <a:r>
+              <a:rPr sz="1700" b="0">
                 <a:solidFill>
                   <a:srgbClr val="1E1B4B"/>
                 </a:solidFill>
                 <a:latin typeface="Calibri"/>
               </a:rPr>
-              <a:t>Header branding, grade tables, embedded charts, and signature blocks.</a:t>
+              <a:t>Header branding, grade tables, embedded chart, signature lines.</a:t>
             </a:r>
           </a:p>
           <a:p>
@@ -6230,26 +6622,26 @@
                 <a:spcPts val="400"/>
               </a:spcBef>
               <a:spcAft>
-                <a:spcPts val="1200"/>
+                <a:spcPts val="1400"/>
               </a:spcAft>
             </a:pPr>
             <a:r>
-              <a:rPr sz="2000" b="1">
+              <a:rPr sz="1900" b="1">
                 <a:solidFill>
                   <a:srgbClr val="3B0764"/>
                 </a:solidFill>
                 <a:latin typeface="Calibri"/>
               </a:rPr>
-              <a:t>• Scalable Output: </a:t>
-            </a:r>
-            <a:r>
-              <a:rPr sz="2000" b="0">
+              <a:t>• Vector Precision: </a:t>
+            </a:r>
+            <a:r>
+              <a:rPr sz="1700" b="0">
                 <a:solidFill>
                   <a:srgbClr val="1E1B4B"/>
                 </a:solidFill>
                 <a:latin typeface="Calibri"/>
               </a:rPr>
-              <a:t>Clean vector PDF ready for immediate printing or official distribution.</a:t>
+              <a:t>High-resolution output suitable for official institutional archives.</a:t>
             </a:r>
           </a:p>
         </p:txBody>
@@ -6270,8 +6662,8 @@
         </p:blipFill>
         <p:spPr>
           <a:xfrm>
-            <a:off x="6217920" y="1691640"/>
-            <a:ext cx="5212080" cy="2746907"/>
+            <a:off x="6217920" y="1600200"/>
+            <a:ext cx="5212080" cy="3705629"/>
           </a:xfrm>
           <a:prstGeom prst="rect">
             <a:avLst/>
@@ -6280,14 +6672,59 @@
       </p:pic>
       <p:sp>
         <p:nvSpPr>
-          <p:cNvPr id="7" name="TextBox 6"/>
+          <p:cNvPr id="7" name="Rectangle 6"/>
+          <p:cNvSpPr/>
+          <p:nvPr/>
+        </p:nvSpPr>
+        <p:spPr>
+          <a:xfrm>
+            <a:off x="731520" y="6263640"/>
+            <a:ext cx="10728655" cy="18288"/>
+          </a:xfrm>
+          <a:prstGeom prst="rect">
+            <a:avLst/>
+          </a:prstGeom>
+          <a:solidFill>
+            <a:srgbClr val="D8B4FE"/>
+          </a:solidFill>
+          <a:ln>
+            <a:solidFill>
+              <a:srgbClr val="D8B4FE"/>
+            </a:solidFill>
+          </a:ln>
+        </p:spPr>
+        <p:style>
+          <a:lnRef idx="1">
+            <a:schemeClr val="accent1"/>
+          </a:lnRef>
+          <a:fillRef idx="3">
+            <a:schemeClr val="accent1"/>
+          </a:fillRef>
+          <a:effectRef idx="2">
+            <a:schemeClr val="accent1"/>
+          </a:effectRef>
+          <a:fontRef idx="minor">
+            <a:schemeClr val="lt1"/>
+          </a:fontRef>
+        </p:style>
+        <p:txBody>
+          <a:bodyPr rtlCol="0" anchor="ctr"/>
+          <a:lstStyle/>
+          <a:p>
+            <a:pPr algn="ctr"/>
+          </a:p>
+        </p:txBody>
+      </p:sp>
+      <p:sp>
+        <p:nvSpPr>
+          <p:cNvPr id="8" name="TextBox 7"/>
           <p:cNvSpPr txBox="1"/>
           <p:nvPr/>
         </p:nvSpPr>
         <p:spPr>
           <a:xfrm>
-            <a:off x="731520" y="6446520"/>
-            <a:ext cx="10698480" cy="320040"/>
+            <a:off x="731520" y="6327648"/>
+            <a:ext cx="10728655" cy="365760"/>
           </a:xfrm>
           <a:prstGeom prst="rect">
             <a:avLst/>
@@ -6301,9 +6738,9 @@
           <a:lstStyle/>
           <a:p>
             <a:pPr>
-              <a:defRPr sz="1100">
-                <a:solidFill>
-                  <a:srgbClr val="6B7280"/>
+              <a:defRPr sz="1600" b="1">
+                <a:solidFill>
+                  <a:srgbClr val="6B468C"/>
                 </a:solidFill>
                 <a:latin typeface="Calibri"/>
               </a:defRPr>
@@ -6328,7 +6765,7 @@
     <p:bg>
       <p:bgPr>
         <a:solidFill>
-          <a:srgbClr val="FFFFFF"/>
+          <a:srgbClr val="FDFBFF"/>
         </a:solidFill>
         <a:effectLst/>
       </p:bgPr>
@@ -6348,8 +6785,8 @@
         </p:nvSpPr>
         <p:spPr>
           <a:xfrm>
-            <a:off x="731520" y="365760"/>
-            <a:ext cx="10698480" cy="1005840"/>
+            <a:off x="731520" y="320040"/>
+            <a:ext cx="10728655" cy="1051560"/>
           </a:xfrm>
           <a:prstGeom prst="rect">
             <a:avLst/>
@@ -6363,7 +6800,7 @@
           <a:lstStyle/>
           <a:p>
             <a:pPr>
-              <a:defRPr sz="3500" b="1">
+              <a:defRPr sz="3400" b="1">
                 <a:solidFill>
                   <a:srgbClr val="3B0764"/>
                 </a:solidFill>
@@ -6376,7 +6813,10 @@
           </a:p>
           <a:p>
             <a:pPr>
-              <a:defRPr sz="2500" b="1">
+              <a:spcBef>
+                <a:spcPts val="400"/>
+              </a:spcBef>
+              <a:defRPr sz="2200" b="1">
                 <a:solidFill>
                   <a:srgbClr val="581C87"/>
                 </a:solidFill>
@@ -6384,7 +6824,7 @@
               </a:defRPr>
             </a:pPr>
             <a:r>
-              <a:t>Streamlit Interactive Dashboard Experience</a:t>
+              <a:t>Reactive Dual-Tab Dashboard with Classroom Demo Presets</a:t>
             </a:r>
           </a:p>
         </p:txBody>
@@ -6397,8 +6837,8 @@
         </p:nvSpPr>
         <p:spPr>
           <a:xfrm>
-            <a:off x="731520" y="1371600"/>
-            <a:ext cx="10698480" cy="36576"/>
+            <a:off x="731520" y="1417320"/>
+            <a:ext cx="10728655" cy="36576"/>
           </a:xfrm>
           <a:prstGeom prst="rect">
             <a:avLst/>
@@ -6436,14 +6876,218 @@
       </p:sp>
       <p:sp>
         <p:nvSpPr>
-          <p:cNvPr id="4" name="Rectangle 3"/>
+          <p:cNvPr id="4" name="Rounded Rectangle 3"/>
           <p:cNvSpPr/>
           <p:nvPr/>
         </p:nvSpPr>
         <p:spPr>
           <a:xfrm>
-            <a:off x="731520" y="6400800"/>
-            <a:ext cx="10698480" cy="18288"/>
+            <a:off x="731520" y="1600200"/>
+            <a:ext cx="5212080" cy="4480560"/>
+          </a:xfrm>
+          <a:prstGeom prst="roundRect">
+            <a:avLst/>
+          </a:prstGeom>
+          <a:solidFill>
+            <a:srgbClr val="F5F0FF"/>
+          </a:solidFill>
+          <a:ln w="19050">
+            <a:solidFill>
+              <a:srgbClr val="D8B4FE"/>
+            </a:solidFill>
+          </a:ln>
+        </p:spPr>
+        <p:style>
+          <a:lnRef idx="1">
+            <a:schemeClr val="accent1"/>
+          </a:lnRef>
+          <a:fillRef idx="3">
+            <a:schemeClr val="accent1"/>
+          </a:fillRef>
+          <a:effectRef idx="2">
+            <a:schemeClr val="accent1"/>
+          </a:effectRef>
+          <a:fontRef idx="minor">
+            <a:schemeClr val="lt1"/>
+          </a:fontRef>
+        </p:style>
+        <p:txBody>
+          <a:bodyPr rtlCol="0" anchor="ctr"/>
+          <a:lstStyle/>
+          <a:p>
+            <a:pPr algn="ctr"/>
+          </a:p>
+        </p:txBody>
+      </p:sp>
+      <p:sp>
+        <p:nvSpPr>
+          <p:cNvPr id="5" name="TextBox 4"/>
+          <p:cNvSpPr txBox="1"/>
+          <p:nvPr/>
+        </p:nvSpPr>
+        <p:spPr>
+          <a:xfrm>
+            <a:off x="960120" y="1783080"/>
+            <a:ext cx="4754880" cy="4114800"/>
+          </a:xfrm>
+          <a:prstGeom prst="rect">
+            <a:avLst/>
+          </a:prstGeom>
+          <a:noFill/>
+        </p:spPr>
+        <p:txBody>
+          <a:bodyPr wrap="square" lIns="0" tIns="0" rIns="0" bIns="0">
+            <a:spAutoFit/>
+          </a:bodyPr>
+          <a:lstStyle/>
+          <a:p>
+            <a:pPr>
+              <a:spcBef>
+                <a:spcPts val="400"/>
+              </a:spcBef>
+              <a:spcAft>
+                <a:spcPts val="1400"/>
+              </a:spcAft>
+            </a:pPr>
+            <a:r>
+              <a:rPr sz="1900" b="1">
+                <a:solidFill>
+                  <a:srgbClr val="3B0764"/>
+                </a:solidFill>
+                <a:latin typeface="Calibri"/>
+              </a:rPr>
+              <a:t>• 1-Click Sidebar Presets: </a:t>
+            </a:r>
+            <a:r>
+              <a:rPr sz="1700" b="0">
+                <a:solidFill>
+                  <a:srgbClr val="1E1B4B"/>
+                </a:solidFill>
+                <a:latin typeface="Calibri"/>
+              </a:rPr>
+              <a:t>Pre-loaded profiles (High Achiever, Needs Review).</a:t>
+            </a:r>
+          </a:p>
+          <a:p>
+            <a:pPr>
+              <a:spcBef>
+                <a:spcPts val="400"/>
+              </a:spcBef>
+              <a:spcAft>
+                <a:spcPts val="1400"/>
+              </a:spcAft>
+            </a:pPr>
+            <a:r>
+              <a:rPr sz="1900" b="1">
+                <a:solidFill>
+                  <a:srgbClr val="3B0764"/>
+                </a:solidFill>
+                <a:latin typeface="Calibri"/>
+              </a:rPr>
+              <a:t>• Dual-Tab Layout: </a:t>
+            </a:r>
+            <a:r>
+              <a:rPr sz="1700" b="0">
+                <a:solidFill>
+                  <a:srgbClr val="1E1B4B"/>
+                </a:solidFill>
+                <a:latin typeface="Calibri"/>
+              </a:rPr>
+              <a:t>Tab 1 for data input; Tab 2 for live report inspection.</a:t>
+            </a:r>
+          </a:p>
+          <a:p>
+            <a:pPr>
+              <a:spcBef>
+                <a:spcPts val="400"/>
+              </a:spcBef>
+              <a:spcAft>
+                <a:spcPts val="1400"/>
+              </a:spcAft>
+            </a:pPr>
+            <a:r>
+              <a:rPr sz="1900" b="1">
+                <a:solidFill>
+                  <a:srgbClr val="3B0764"/>
+                </a:solidFill>
+                <a:latin typeface="Calibri"/>
+              </a:rPr>
+              <a:t>• Live KPI Summary: </a:t>
+            </a:r>
+            <a:r>
+              <a:rPr sz="1700" b="0">
+                <a:solidFill>
+                  <a:srgbClr val="1E1B4B"/>
+                </a:solidFill>
+                <a:latin typeface="Calibri"/>
+              </a:rPr>
+              <a:t>Instant metrics for Total Marks, Aggregate %, Standing.</a:t>
+            </a:r>
+          </a:p>
+          <a:p>
+            <a:pPr>
+              <a:spcBef>
+                <a:spcPts val="400"/>
+              </a:spcBef>
+              <a:spcAft>
+                <a:spcPts val="1400"/>
+              </a:spcAft>
+            </a:pPr>
+            <a:r>
+              <a:rPr sz="1900" b="1">
+                <a:solidFill>
+                  <a:srgbClr val="3B0764"/>
+                </a:solidFill>
+                <a:latin typeface="Calibri"/>
+              </a:rPr>
+              <a:t>• In-Memory Download: </a:t>
+            </a:r>
+            <a:r>
+              <a:rPr sz="1700" b="0">
+                <a:solidFill>
+                  <a:srgbClr val="1E1B4B"/>
+                </a:solidFill>
+                <a:latin typeface="Calibri"/>
+              </a:rPr>
+              <a:t>1-Click download of vector PDF without file locking.</a:t>
+            </a:r>
+          </a:p>
+        </p:txBody>
+      </p:sp>
+      <p:pic>
+        <p:nvPicPr>
+          <p:cNvPr id="6" name="Picture 5" descr="slide9_dashboard.png"/>
+          <p:cNvPicPr>
+            <a:picLocks noChangeAspect="1"/>
+          </p:cNvPicPr>
+          <p:nvPr/>
+        </p:nvPicPr>
+        <p:blipFill>
+          <a:blip r:embed="rId2"/>
+          <a:stretch>
+            <a:fillRect/>
+          </a:stretch>
+        </p:blipFill>
+        <p:spPr>
+          <a:xfrm>
+            <a:off x="6217920" y="1600200"/>
+            <a:ext cx="5212080" cy="3451242"/>
+          </a:xfrm>
+          <a:prstGeom prst="rect">
+            <a:avLst/>
+          </a:prstGeom>
+        </p:spPr>
+      </p:pic>
+      <p:sp>
+        <p:nvSpPr>
+          <p:cNvPr id="7" name="Rectangle 6"/>
+          <p:cNvSpPr/>
+          <p:nvPr/>
+        </p:nvSpPr>
+        <p:spPr>
+          <a:xfrm>
+            <a:off x="731520" y="6263640"/>
+            <a:ext cx="10728655" cy="18288"/>
           </a:xfrm>
           <a:prstGeom prst="rect">
             <a:avLst/>
@@ -6481,14 +7125,14 @@
       </p:sp>
       <p:sp>
         <p:nvSpPr>
-          <p:cNvPr id="5" name="TextBox 4"/>
+          <p:cNvPr id="8" name="TextBox 7"/>
           <p:cNvSpPr txBox="1"/>
           <p:nvPr/>
         </p:nvSpPr>
         <p:spPr>
           <a:xfrm>
-            <a:off x="731520" y="1645920"/>
-            <a:ext cx="10698480" cy="4572000"/>
+            <a:off x="731520" y="6327648"/>
+            <a:ext cx="10728655" cy="365760"/>
           </a:xfrm>
           <a:prstGeom prst="rect">
             <a:avLst/>
@@ -6496,150 +7140,15 @@
           <a:noFill/>
         </p:spPr>
         <p:txBody>
-          <a:bodyPr wrap="square" lIns="0" tIns="0" rIns="0" bIns="0">
-            <a:spAutoFit/>
-          </a:bodyPr>
-          <a:lstStyle/>
-          <a:p>
-            <a:pPr>
-              <a:spcBef>
-                <a:spcPts val="400"/>
-              </a:spcBef>
-              <a:spcAft>
-                <a:spcPts val="1200"/>
-              </a:spcAft>
-            </a:pPr>
-            <a:r>
-              <a:rPr sz="2000" b="1">
-                <a:solidFill>
-                  <a:srgbClr val="3B0764"/>
-                </a:solidFill>
-                <a:latin typeface="Calibri"/>
-              </a:rPr>
-              <a:t>• Quick Demo Presets: </a:t>
-            </a:r>
-            <a:r>
-              <a:rPr sz="2000" b="0">
-                <a:solidFill>
-                  <a:srgbClr val="1E1B4B"/>
-                </a:solidFill>
-                <a:latin typeface="Calibri"/>
-              </a:rPr>
-              <a:t>Sidebar allows 1-click loading of student profiles (High Achiever, Needs Review).</a:t>
-            </a:r>
-          </a:p>
-          <a:p>
-            <a:pPr>
-              <a:spcBef>
-                <a:spcPts val="400"/>
-              </a:spcBef>
-              <a:spcAft>
-                <a:spcPts val="1200"/>
-              </a:spcAft>
-            </a:pPr>
-            <a:r>
-              <a:rPr sz="2000" b="1">
-                <a:solidFill>
-                  <a:srgbClr val="3B0764"/>
-                </a:solidFill>
-                <a:latin typeface="Calibri"/>
-              </a:rPr>
-              <a:t>• Dual-Tab Interface: </a:t>
-            </a:r>
-            <a:r>
-              <a:rPr sz="2000" b="0">
-                <a:solidFill>
-                  <a:srgbClr val="1E1B4B"/>
-                </a:solidFill>
-                <a:latin typeface="Calibri"/>
-              </a:rPr>
-              <a:t>Tab 1 for intuitive record entry; Tab 2 for live report inspection &amp; download.</a:t>
-            </a:r>
-          </a:p>
-          <a:p>
-            <a:pPr>
-              <a:spcBef>
-                <a:spcPts val="400"/>
-              </a:spcBef>
-              <a:spcAft>
-                <a:spcPts val="1200"/>
-              </a:spcAft>
-            </a:pPr>
-            <a:r>
-              <a:rPr sz="2000" b="1">
-                <a:solidFill>
-                  <a:srgbClr val="3B0764"/>
-                </a:solidFill>
-                <a:latin typeface="Calibri"/>
-              </a:rPr>
-              <a:t>• Real-Time KPI Cards: </a:t>
-            </a:r>
-            <a:r>
-              <a:rPr sz="2000" b="0">
-                <a:solidFill>
-                  <a:srgbClr val="1E1B4B"/>
-                </a:solidFill>
-                <a:latin typeface="Calibri"/>
-              </a:rPr>
-              <a:t>Displays Total Marks, Aggregate %, Standing Badge, and Attendance.</a:t>
-            </a:r>
-          </a:p>
-          <a:p>
-            <a:pPr>
-              <a:spcBef>
-                <a:spcPts val="400"/>
-              </a:spcBef>
-              <a:spcAft>
-                <a:spcPts val="1200"/>
-              </a:spcAft>
-            </a:pPr>
-            <a:r>
-              <a:rPr sz="2000" b="1">
-                <a:solidFill>
-                  <a:srgbClr val="3B0764"/>
-                </a:solidFill>
-                <a:latin typeface="Calibri"/>
-              </a:rPr>
-              <a:t>• One-Click PDF Download: </a:t>
-            </a:r>
-            <a:r>
-              <a:rPr sz="2000" b="0">
-                <a:solidFill>
-                  <a:srgbClr val="1E1B4B"/>
-                </a:solidFill>
-                <a:latin typeface="Calibri"/>
-              </a:rPr>
-              <a:t>Streamlit download button serves vector-quality report on demand.</a:t>
-            </a:r>
-          </a:p>
-        </p:txBody>
-      </p:sp>
-      <p:sp>
-        <p:nvSpPr>
-          <p:cNvPr id="6" name="TextBox 5"/>
-          <p:cNvSpPr txBox="1"/>
-          <p:nvPr/>
-        </p:nvSpPr>
-        <p:spPr>
-          <a:xfrm>
-            <a:off x="731520" y="6446520"/>
-            <a:ext cx="10698480" cy="320040"/>
-          </a:xfrm>
-          <a:prstGeom prst="rect">
-            <a:avLst/>
-          </a:prstGeom>
-          <a:noFill/>
-        </p:spPr>
-        <p:txBody>
           <a:bodyPr wrap="none">
             <a:spAutoFit/>
           </a:bodyPr>
           <a:lstStyle/>
           <a:p>
             <a:pPr>
-              <a:defRPr sz="1100">
-                <a:solidFill>
-                  <a:srgbClr val="6B7280"/>
+              <a:defRPr sz="1600" b="1">
+                <a:solidFill>
+                  <a:srgbClr val="6B468C"/>
                 </a:solidFill>
                 <a:latin typeface="Calibri"/>
               </a:defRPr>

</xml_diff>

<commit_message>
Fix button text contrast with crisp white text and clean professional academic typography
</commit_message>
<xml_diff>
--- a/presentation/personalized_report_presentation.pptx
+++ b/presentation/personalized_report_presentation.pptx
@@ -6663,7 +6663,7 @@
         <p:spPr>
           <a:xfrm>
             <a:off x="6217920" y="1600200"/>
-            <a:ext cx="5212080" cy="3705629"/>
+            <a:ext cx="5212080" cy="3615401"/>
           </a:xfrm>
           <a:prstGeom prst="rect">
             <a:avLst/>
@@ -6956,7 +6956,7 @@
                 </a:solidFill>
                 <a:latin typeface="Calibri"/>
               </a:rPr>
-              <a:t>• 1-Click Sidebar Presets: </a:t>
+              <a:t>• 1-Click MCA Presets: </a:t>
             </a:r>
             <a:r>
               <a:rPr sz="1700" b="0">
@@ -6965,7 +6965,7 @@
                 </a:solidFill>
                 <a:latin typeface="Calibri"/>
               </a:rPr>
-              <a:t>Pre-loaded profiles (High Achiever, Needs Review).</a:t>
+              <a:t>Pre-loaded profiles: Induja, Bhuvisha, Kumar, Rajesh, Dhivya (25MX---).</a:t>
             </a:r>
           </a:p>
           <a:p>

</xml_diff>